<commit_message>
style: overhaul presentation deck to clean executive light theme
</commit_message>
<xml_diff>
--- a/ChainReaction_Architecture_Presentation.pptx
+++ b/ChainReaction_Architecture_Presentation.pptx
@@ -3114,7 +3114,7 @@
             <a:avLst/>
           </a:prstGeom>
           <a:solidFill>
-            <a:srgbClr val="0B0F19"/>
+            <a:srgbClr val="F8FAFC"/>
           </a:solidFill>
           <a:ln>
             <a:noFill/>
@@ -3150,18 +3150,18 @@
         </p:nvSpPr>
         <p:spPr>
           <a:xfrm>
-            <a:off x="822960" y="1005840"/>
+            <a:off x="822960" y="960120"/>
             <a:ext cx="3291840" cy="329184"/>
           </a:xfrm>
           <a:prstGeom prst="roundRect">
             <a:avLst/>
           </a:prstGeom>
           <a:solidFill>
-            <a:srgbClr val="161E2E"/>
+            <a:srgbClr val="ECFDF5"/>
           </a:solidFill>
           <a:ln w="12700">
             <a:solidFill>
-              <a:srgbClr val="10B981"/>
+              <a:srgbClr val="A7F3D0"/>
             </a:solidFill>
           </a:ln>
         </p:spPr>
@@ -3186,7 +3186,7 @@
             <a:pPr algn="ctr">
               <a:defRPr sz="1100" b="1">
                 <a:solidFill>
-                  <a:srgbClr val="10B981"/>
+                  <a:srgbClr val="059669"/>
                 </a:solidFill>
               </a:defRPr>
             </a:pPr>
@@ -3204,7 +3204,7 @@
         </p:nvSpPr>
         <p:spPr>
           <a:xfrm>
-            <a:off x="822960" y="1508760"/>
+            <a:off x="822960" y="1417320"/>
             <a:ext cx="10515600" cy="1463040"/>
           </a:xfrm>
           <a:prstGeom prst="rect">
@@ -3221,7 +3221,7 @@
             <a:pPr>
               <a:defRPr sz="4400" b="1">
                 <a:solidFill>
-                  <a:srgbClr val="F8FAFC"/>
+                  <a:srgbClr val="0F172A"/>
                 </a:solidFill>
                 <a:latin typeface="Segoe UI"/>
               </a:defRPr>
@@ -3237,7 +3237,7 @@
               </a:spcBef>
               <a:defRPr sz="1800">
                 <a:solidFill>
-                  <a:srgbClr val="06B6D4"/>
+                  <a:srgbClr val="0284C7"/>
                 </a:solidFill>
               </a:defRPr>
             </a:pPr>
@@ -3262,11 +3262,11 @@
             <a:avLst/>
           </a:prstGeom>
           <a:solidFill>
-            <a:srgbClr val="161E2E"/>
+            <a:srgbClr val="FFFFFF"/>
           </a:solidFill>
-          <a:ln w="12700">
+          <a:ln w="15240">
             <a:solidFill>
-              <a:srgbClr val="2D3C54"/>
+              <a:srgbClr val="E2E8F0"/>
             </a:solidFill>
           </a:ln>
         </p:spPr>
@@ -3317,7 +3317,7 @@
             <a:pPr>
               <a:defRPr sz="2800" b="1">
                 <a:solidFill>
-                  <a:srgbClr val="06B6D4"/>
+                  <a:srgbClr val="0284C7"/>
                 </a:solidFill>
                 <a:latin typeface="Segoe UI"/>
               </a:defRPr>
@@ -3333,7 +3333,7 @@
               </a:spcBef>
               <a:defRPr sz="1300" b="1">
                 <a:solidFill>
-                  <a:srgbClr val="F8FAFC"/>
+                  <a:srgbClr val="0F172A"/>
                 </a:solidFill>
               </a:defRPr>
             </a:pPr>
@@ -3348,7 +3348,7 @@
               </a:spcBef>
               <a:defRPr sz="1100">
                 <a:solidFill>
-                  <a:srgbClr val="9CAFC9"/>
+                  <a:srgbClr val="64748B"/>
                 </a:solidFill>
               </a:defRPr>
             </a:pPr>
@@ -3373,11 +3373,11 @@
             <a:avLst/>
           </a:prstGeom>
           <a:solidFill>
-            <a:srgbClr val="161E2E"/>
+            <a:srgbClr val="FFFFFF"/>
           </a:solidFill>
-          <a:ln w="12700">
+          <a:ln w="15240">
             <a:solidFill>
-              <a:srgbClr val="2D3C54"/>
+              <a:srgbClr val="E2E8F0"/>
             </a:solidFill>
           </a:ln>
         </p:spPr>
@@ -3428,7 +3428,7 @@
             <a:pPr>
               <a:defRPr sz="2800" b="1">
                 <a:solidFill>
-                  <a:srgbClr val="A855F7"/>
+                  <a:srgbClr val="4F46E5"/>
                 </a:solidFill>
                 <a:latin typeface="Segoe UI"/>
               </a:defRPr>
@@ -3444,7 +3444,7 @@
               </a:spcBef>
               <a:defRPr sz="1300" b="1">
                 <a:solidFill>
-                  <a:srgbClr val="F8FAFC"/>
+                  <a:srgbClr val="0F172A"/>
                 </a:solidFill>
               </a:defRPr>
             </a:pPr>
@@ -3459,7 +3459,7 @@
               </a:spcBef>
               <a:defRPr sz="1100">
                 <a:solidFill>
-                  <a:srgbClr val="9CAFC9"/>
+                  <a:srgbClr val="64748B"/>
                 </a:solidFill>
               </a:defRPr>
             </a:pPr>
@@ -3484,11 +3484,11 @@
             <a:avLst/>
           </a:prstGeom>
           <a:solidFill>
-            <a:srgbClr val="161E2E"/>
+            <a:srgbClr val="FFFFFF"/>
           </a:solidFill>
-          <a:ln w="12700">
+          <a:ln w="15240">
             <a:solidFill>
-              <a:srgbClr val="2D3C54"/>
+              <a:srgbClr val="E2E8F0"/>
             </a:solidFill>
           </a:ln>
         </p:spPr>
@@ -3539,7 +3539,7 @@
             <a:pPr>
               <a:defRPr sz="2800" b="1">
                 <a:solidFill>
-                  <a:srgbClr val="10B981"/>
+                  <a:srgbClr val="059669"/>
                 </a:solidFill>
                 <a:latin typeface="Segoe UI"/>
               </a:defRPr>
@@ -3555,7 +3555,7 @@
               </a:spcBef>
               <a:defRPr sz="1300" b="1">
                 <a:solidFill>
-                  <a:srgbClr val="F8FAFC"/>
+                  <a:srgbClr val="0F172A"/>
                 </a:solidFill>
               </a:defRPr>
             </a:pPr>
@@ -3570,7 +3570,7 @@
               </a:spcBef>
               <a:defRPr sz="1100">
                 <a:solidFill>
-                  <a:srgbClr val="9CAFC9"/>
+                  <a:srgbClr val="64748B"/>
                 </a:solidFill>
               </a:defRPr>
             </a:pPr>
@@ -3648,7 +3648,7 @@
             <a:avLst/>
           </a:prstGeom>
           <a:solidFill>
-            <a:srgbClr val="0B0F19"/>
+            <a:srgbClr val="F8FAFC"/>
           </a:solidFill>
           <a:ln>
             <a:noFill/>
@@ -3684,18 +3684,18 @@
         </p:nvSpPr>
         <p:spPr>
           <a:xfrm>
-            <a:off x="731520" y="365760"/>
-            <a:ext cx="2651760" cy="292608"/>
+            <a:off x="731520" y="347472"/>
+            <a:ext cx="2926080" cy="292608"/>
           </a:xfrm>
           <a:prstGeom prst="roundRect">
             <a:avLst/>
           </a:prstGeom>
           <a:solidFill>
-            <a:srgbClr val="161E2E"/>
+            <a:srgbClr val="EEF2FF"/>
           </a:solidFill>
           <a:ln w="12700">
             <a:solidFill>
-              <a:srgbClr val="A855F7"/>
+              <a:srgbClr val="C7D2FE"/>
             </a:solidFill>
           </a:ln>
         </p:spPr>
@@ -3720,7 +3720,7 @@
             <a:pPr algn="ctr">
               <a:defRPr sz="1000" b="1">
                 <a:solidFill>
-                  <a:srgbClr val="A855F7"/>
+                  <a:srgbClr val="4F46E5"/>
                 </a:solidFill>
                 <a:latin typeface="Segoe UI"/>
               </a:defRPr>
@@ -3739,7 +3739,7 @@
         </p:nvSpPr>
         <p:spPr>
           <a:xfrm>
-            <a:off x="731520" y="713232"/>
+            <a:off x="731520" y="694944"/>
             <a:ext cx="10698480" cy="594360"/>
           </a:xfrm>
           <a:prstGeom prst="rect">
@@ -3756,7 +3756,7 @@
             <a:pPr>
               <a:defRPr sz="2400" b="1">
                 <a:solidFill>
-                  <a:srgbClr val="F8FAFC"/>
+                  <a:srgbClr val="0F172A"/>
                 </a:solidFill>
                 <a:latin typeface="Segoe UI"/>
               </a:defRPr>
@@ -3782,11 +3782,11 @@
             <a:avLst/>
           </a:prstGeom>
           <a:solidFill>
-            <a:srgbClr val="161E2E"/>
+            <a:srgbClr val="FFFFFF"/>
           </a:solidFill>
-          <a:ln w="12700">
+          <a:ln w="15240">
             <a:solidFill>
-              <a:srgbClr val="2D3C54"/>
+              <a:srgbClr val="E2E8F0"/>
             </a:solidFill>
           </a:ln>
         </p:spPr>
@@ -3837,7 +3837,7 @@
             <a:pPr>
               <a:defRPr sz="1400" b="1">
                 <a:solidFill>
-                  <a:srgbClr val="A855F7"/>
+                  <a:srgbClr val="4F46E5"/>
                 </a:solidFill>
                 <a:latin typeface="Segoe UI"/>
               </a:defRPr>
@@ -3881,7 +3881,7 @@
             <a:r>
               <a:rPr b="1" sz="1200">
                 <a:solidFill>
-                  <a:srgbClr val="F8FAFC"/>
+                  <a:srgbClr val="0F172A"/>
                 </a:solidFill>
                 <a:latin typeface="Segoe UI"/>
               </a:rPr>
@@ -3890,7 +3890,7 @@
             <a:r>
               <a:rPr sz="1200">
                 <a:solidFill>
-                  <a:srgbClr val="9CAFC9"/>
+                  <a:srgbClr val="334155"/>
                 </a:solidFill>
                 <a:latin typeface="Segoe UI"/>
               </a:rPr>
@@ -3910,7 +3910,7 @@
             <a:r>
               <a:rPr b="1" sz="1200">
                 <a:solidFill>
-                  <a:srgbClr val="F8FAFC"/>
+                  <a:srgbClr val="0F172A"/>
                 </a:solidFill>
                 <a:latin typeface="Segoe UI"/>
               </a:rPr>
@@ -3919,7 +3919,7 @@
             <a:r>
               <a:rPr sz="1200">
                 <a:solidFill>
-                  <a:srgbClr val="9CAFC9"/>
+                  <a:srgbClr val="334155"/>
                 </a:solidFill>
                 <a:latin typeface="Segoe UI"/>
               </a:rPr>
@@ -3938,7 +3938,7 @@
             <a:r>
               <a:rPr b="1" sz="1200">
                 <a:solidFill>
-                  <a:srgbClr val="F8FAFC"/>
+                  <a:srgbClr val="0F172A"/>
                 </a:solidFill>
                 <a:latin typeface="Segoe UI"/>
               </a:rPr>
@@ -3947,7 +3947,7 @@
             <a:r>
               <a:rPr sz="1200">
                 <a:solidFill>
-                  <a:srgbClr val="9CAFC9"/>
+                  <a:srgbClr val="334155"/>
                 </a:solidFill>
                 <a:latin typeface="Segoe UI"/>
               </a:rPr>
@@ -3972,11 +3972,11 @@
             <a:avLst/>
           </a:prstGeom>
           <a:solidFill>
-            <a:srgbClr val="161E2E"/>
+            <a:srgbClr val="FFFFFF"/>
           </a:solidFill>
-          <a:ln w="12700">
+          <a:ln w="15240">
             <a:solidFill>
-              <a:srgbClr val="2D3C54"/>
+              <a:srgbClr val="E2E8F0"/>
             </a:solidFill>
           </a:ln>
         </p:spPr>
@@ -4027,7 +4027,7 @@
             <a:pPr>
               <a:defRPr sz="1400" b="1">
                 <a:solidFill>
-                  <a:srgbClr val="EF4444"/>
+                  <a:srgbClr val="DC2626"/>
                 </a:solidFill>
                 <a:latin typeface="Segoe UI"/>
               </a:defRPr>
@@ -4071,7 +4071,7 @@
             <a:r>
               <a:rPr b="1" sz="1200">
                 <a:solidFill>
-                  <a:srgbClr val="F8FAFC"/>
+                  <a:srgbClr val="0F172A"/>
                 </a:solidFill>
                 <a:latin typeface="Segoe UI"/>
               </a:rPr>
@@ -4080,7 +4080,7 @@
             <a:r>
               <a:rPr sz="1200">
                 <a:solidFill>
-                  <a:srgbClr val="9CAFC9"/>
+                  <a:srgbClr val="334155"/>
                 </a:solidFill>
                 <a:latin typeface="Segoe UI"/>
               </a:rPr>
@@ -4099,7 +4099,7 @@
             <a:r>
               <a:rPr b="1" sz="1200">
                 <a:solidFill>
-                  <a:srgbClr val="F8FAFC"/>
+                  <a:srgbClr val="0F172A"/>
                 </a:solidFill>
                 <a:latin typeface="Segoe UI"/>
               </a:rPr>
@@ -4108,7 +4108,7 @@
             <a:r>
               <a:rPr sz="1200">
                 <a:solidFill>
-                  <a:srgbClr val="9CAFC9"/>
+                  <a:srgbClr val="334155"/>
                 </a:solidFill>
                 <a:latin typeface="Segoe UI"/>
               </a:rPr>
@@ -4127,7 +4127,7 @@
             <a:r>
               <a:rPr b="1" sz="1200">
                 <a:solidFill>
-                  <a:srgbClr val="F8FAFC"/>
+                  <a:srgbClr val="0F172A"/>
                 </a:solidFill>
                 <a:latin typeface="Segoe UI"/>
               </a:rPr>
@@ -4136,7 +4136,7 @@
             <a:r>
               <a:rPr sz="1200">
                 <a:solidFill>
-                  <a:srgbClr val="9CAFC9"/>
+                  <a:srgbClr val="334155"/>
                 </a:solidFill>
                 <a:latin typeface="Segoe UI"/>
               </a:rPr>
@@ -4155,7 +4155,7 @@
             <a:r>
               <a:rPr b="1" sz="1200">
                 <a:solidFill>
-                  <a:srgbClr val="F8FAFC"/>
+                  <a:srgbClr val="0F172A"/>
                 </a:solidFill>
                 <a:latin typeface="Segoe UI"/>
               </a:rPr>
@@ -4164,7 +4164,7 @@
             <a:r>
               <a:rPr sz="1200">
                 <a:solidFill>
-                  <a:srgbClr val="9CAFC9"/>
+                  <a:srgbClr val="334155"/>
                 </a:solidFill>
                 <a:latin typeface="Segoe UI"/>
               </a:rPr>
@@ -4206,7 +4206,7 @@
             <a:avLst/>
           </a:prstGeom>
           <a:solidFill>
-            <a:srgbClr val="0B0F19"/>
+            <a:srgbClr val="F8FAFC"/>
           </a:solidFill>
           <a:ln>
             <a:noFill/>
@@ -4242,18 +4242,18 @@
         </p:nvSpPr>
         <p:spPr>
           <a:xfrm>
-            <a:off x="731520" y="365760"/>
-            <a:ext cx="2651760" cy="292608"/>
+            <a:off x="731520" y="347472"/>
+            <a:ext cx="2926080" cy="292608"/>
           </a:xfrm>
           <a:prstGeom prst="roundRect">
             <a:avLst/>
           </a:prstGeom>
           <a:solidFill>
-            <a:srgbClr val="161E2E"/>
+            <a:srgbClr val="EFF6FF"/>
           </a:solidFill>
           <a:ln w="12700">
             <a:solidFill>
-              <a:srgbClr val="06B6D4"/>
+              <a:srgbClr val="BFDBFE"/>
             </a:solidFill>
           </a:ln>
         </p:spPr>
@@ -4278,7 +4278,7 @@
             <a:pPr algn="ctr">
               <a:defRPr sz="1000" b="1">
                 <a:solidFill>
-                  <a:srgbClr val="06B6D4"/>
+                  <a:srgbClr val="0284C7"/>
                 </a:solidFill>
                 <a:latin typeface="Segoe UI"/>
               </a:defRPr>
@@ -4297,7 +4297,7 @@
         </p:nvSpPr>
         <p:spPr>
           <a:xfrm>
-            <a:off x="731520" y="713232"/>
+            <a:off x="731520" y="694944"/>
             <a:ext cx="10698480" cy="594360"/>
           </a:xfrm>
           <a:prstGeom prst="rect">
@@ -4314,7 +4314,7 @@
             <a:pPr>
               <a:defRPr sz="2400" b="1">
                 <a:solidFill>
-                  <a:srgbClr val="F8FAFC"/>
+                  <a:srgbClr val="0F172A"/>
                 </a:solidFill>
                 <a:latin typeface="Segoe UI"/>
               </a:defRPr>
@@ -4340,11 +4340,11 @@
             <a:avLst/>
           </a:prstGeom>
           <a:solidFill>
-            <a:srgbClr val="161E2E"/>
+            <a:srgbClr val="FFFFFF"/>
           </a:solidFill>
-          <a:ln w="12700">
+          <a:ln w="15240">
             <a:solidFill>
-              <a:srgbClr val="2D3C54"/>
+              <a:srgbClr val="E2E8F0"/>
             </a:solidFill>
           </a:ln>
         </p:spPr>
@@ -4395,7 +4395,7 @@
             <a:pPr>
               <a:defRPr sz="1400" b="1">
                 <a:solidFill>
-                  <a:srgbClr val="06B6D4"/>
+                  <a:srgbClr val="0284C7"/>
                 </a:solidFill>
                 <a:latin typeface="Segoe UI"/>
               </a:defRPr>
@@ -4439,7 +4439,7 @@
             <a:r>
               <a:rPr b="1" sz="1200">
                 <a:solidFill>
-                  <a:srgbClr val="F8FAFC"/>
+                  <a:srgbClr val="0F172A"/>
                 </a:solidFill>
                 <a:latin typeface="Segoe UI"/>
               </a:rPr>
@@ -4448,7 +4448,7 @@
             <a:r>
               <a:rPr sz="1200">
                 <a:solidFill>
-                  <a:srgbClr val="9CAFC9"/>
+                  <a:srgbClr val="334155"/>
                 </a:solidFill>
                 <a:latin typeface="Segoe UI"/>
               </a:rPr>
@@ -4467,7 +4467,7 @@
             <a:r>
               <a:rPr b="1" sz="1200">
                 <a:solidFill>
-                  <a:srgbClr val="F8FAFC"/>
+                  <a:srgbClr val="0F172A"/>
                 </a:solidFill>
                 <a:latin typeface="Segoe UI"/>
               </a:rPr>
@@ -4476,7 +4476,7 @@
             <a:r>
               <a:rPr sz="1200">
                 <a:solidFill>
-                  <a:srgbClr val="9CAFC9"/>
+                  <a:srgbClr val="334155"/>
                 </a:solidFill>
                 <a:latin typeface="Segoe UI"/>
               </a:rPr>
@@ -4495,7 +4495,7 @@
             <a:r>
               <a:rPr b="1" sz="1200">
                 <a:solidFill>
-                  <a:srgbClr val="F8FAFC"/>
+                  <a:srgbClr val="0F172A"/>
                 </a:solidFill>
                 <a:latin typeface="Segoe UI"/>
               </a:rPr>
@@ -4504,7 +4504,7 @@
             <a:r>
               <a:rPr sz="1200">
                 <a:solidFill>
-                  <a:srgbClr val="9CAFC9"/>
+                  <a:srgbClr val="334155"/>
                 </a:solidFill>
                 <a:latin typeface="Segoe UI"/>
               </a:rPr>
@@ -4523,7 +4523,7 @@
             <a:r>
               <a:rPr b="1" sz="1200">
                 <a:solidFill>
-                  <a:srgbClr val="F8FAFC"/>
+                  <a:srgbClr val="0F172A"/>
                 </a:solidFill>
                 <a:latin typeface="Segoe UI"/>
               </a:rPr>
@@ -4532,7 +4532,7 @@
             <a:r>
               <a:rPr sz="1200">
                 <a:solidFill>
-                  <a:srgbClr val="9CAFC9"/>
+                  <a:srgbClr val="334155"/>
                 </a:solidFill>
                 <a:latin typeface="Segoe UI"/>
               </a:rPr>
@@ -4556,11 +4556,11 @@
             <a:avLst/>
           </a:prstGeom>
           <a:solidFill>
-            <a:srgbClr val="161E2E"/>
+            <a:srgbClr val="FFFFFF"/>
           </a:solidFill>
-          <a:ln w="12700">
+          <a:ln w="15240">
             <a:solidFill>
-              <a:srgbClr val="2D3C54"/>
+              <a:srgbClr val="E2E8F0"/>
             </a:solidFill>
           </a:ln>
         </p:spPr>
@@ -4611,7 +4611,7 @@
             <a:pPr>
               <a:defRPr sz="1400" b="1">
                 <a:solidFill>
-                  <a:srgbClr val="10B981"/>
+                  <a:srgbClr val="059669"/>
                 </a:solidFill>
                 <a:latin typeface="Segoe UI"/>
               </a:defRPr>
@@ -4637,11 +4637,11 @@
             <a:avLst/>
           </a:prstGeom>
           <a:solidFill>
-            <a:srgbClr val="0F172A"/>
+            <a:srgbClr val="FFFFFF"/>
           </a:solidFill>
-          <a:ln w="12700">
+          <a:ln w="15240">
             <a:solidFill>
-              <a:srgbClr val="334155"/>
+              <a:srgbClr val="E2E8F0"/>
             </a:solidFill>
           </a:ln>
         </p:spPr>
@@ -4724,7 +4724,7 @@
             <a:avLst/>
           </a:prstGeom>
           <a:solidFill>
-            <a:srgbClr val="0B0F19"/>
+            <a:srgbClr val="F8FAFC"/>
           </a:solidFill>
           <a:ln>
             <a:noFill/>
@@ -4760,18 +4760,18 @@
         </p:nvSpPr>
         <p:spPr>
           <a:xfrm>
-            <a:off x="731520" y="365760"/>
-            <a:ext cx="2651760" cy="292608"/>
+            <a:off x="731520" y="347472"/>
+            <a:ext cx="2926080" cy="292608"/>
           </a:xfrm>
           <a:prstGeom prst="roundRect">
             <a:avLst/>
           </a:prstGeom>
           <a:solidFill>
-            <a:srgbClr val="161E2E"/>
+            <a:srgbClr val="ECFDF5"/>
           </a:solidFill>
           <a:ln w="12700">
             <a:solidFill>
-              <a:srgbClr val="10B981"/>
+              <a:srgbClr val="A7F3D0"/>
             </a:solidFill>
           </a:ln>
         </p:spPr>
@@ -4796,7 +4796,7 @@
             <a:pPr algn="ctr">
               <a:defRPr sz="1000" b="1">
                 <a:solidFill>
-                  <a:srgbClr val="10B981"/>
+                  <a:srgbClr val="059669"/>
                 </a:solidFill>
                 <a:latin typeface="Segoe UI"/>
               </a:defRPr>
@@ -4815,7 +4815,7 @@
         </p:nvSpPr>
         <p:spPr>
           <a:xfrm>
-            <a:off x="731520" y="713232"/>
+            <a:off x="731520" y="694944"/>
             <a:ext cx="10698480" cy="594360"/>
           </a:xfrm>
           <a:prstGeom prst="rect">
@@ -4832,7 +4832,7 @@
             <a:pPr>
               <a:defRPr sz="2400" b="1">
                 <a:solidFill>
-                  <a:srgbClr val="F8FAFC"/>
+                  <a:srgbClr val="0F172A"/>
                 </a:solidFill>
                 <a:latin typeface="Segoe UI"/>
               </a:defRPr>
@@ -4877,7 +4877,7 @@
                       <a:pPr>
                         <a:defRPr b="1" sz="1100">
                           <a:solidFill>
-                            <a:srgbClr val="F8FAFC"/>
+                            <a:srgbClr val="0F172A"/>
                           </a:solidFill>
                         </a:defRPr>
                       </a:pPr>
@@ -4888,7 +4888,7 @@
                   </a:txBody>
                   <a:tcPr anchor="ctr">
                     <a:solidFill>
-                      <a:srgbClr val="161E2E"/>
+                      <a:srgbClr val="F1F5F9"/>
                     </a:solidFill>
                   </a:tcPr>
                 </a:tc>
@@ -4900,7 +4900,7 @@
                       <a:pPr>
                         <a:defRPr b="1" sz="1100">
                           <a:solidFill>
-                            <a:srgbClr val="F8FAFC"/>
+                            <a:srgbClr val="0F172A"/>
                           </a:solidFill>
                         </a:defRPr>
                       </a:pPr>
@@ -4911,7 +4911,7 @@
                   </a:txBody>
                   <a:tcPr anchor="ctr">
                     <a:solidFill>
-                      <a:srgbClr val="161E2E"/>
+                      <a:srgbClr val="F1F5F9"/>
                     </a:solidFill>
                   </a:tcPr>
                 </a:tc>
@@ -4923,7 +4923,7 @@
                       <a:pPr>
                         <a:defRPr b="1" sz="1100">
                           <a:solidFill>
-                            <a:srgbClr val="10B981"/>
+                            <a:srgbClr val="059669"/>
                           </a:solidFill>
                         </a:defRPr>
                       </a:pPr>
@@ -4934,7 +4934,7 @@
                   </a:txBody>
                   <a:tcPr anchor="ctr">
                     <a:solidFill>
-                      <a:srgbClr val="161E2E"/>
+                      <a:srgbClr val="F1F5F9"/>
                     </a:solidFill>
                   </a:tcPr>
                 </a:tc>
@@ -4946,7 +4946,7 @@
                       <a:pPr>
                         <a:defRPr b="1" sz="1100">
                           <a:solidFill>
-                            <a:srgbClr val="06B6D4"/>
+                            <a:srgbClr val="0284C7"/>
                           </a:solidFill>
                         </a:defRPr>
                       </a:pPr>
@@ -4957,7 +4957,7 @@
                   </a:txBody>
                   <a:tcPr anchor="ctr">
                     <a:solidFill>
-                      <a:srgbClr val="161E2E"/>
+                      <a:srgbClr val="F1F5F9"/>
                     </a:solidFill>
                   </a:tcPr>
                 </a:tc>
@@ -4969,7 +4969,7 @@
                       <a:pPr>
                         <a:defRPr b="1" sz="1100">
                           <a:solidFill>
-                            <a:srgbClr val="A855F7"/>
+                            <a:srgbClr val="4F46E5"/>
                           </a:solidFill>
                         </a:defRPr>
                       </a:pPr>
@@ -4980,7 +4980,7 @@
                   </a:txBody>
                   <a:tcPr anchor="ctr">
                     <a:solidFill>
-                      <a:srgbClr val="161E2E"/>
+                      <a:srgbClr val="F1F5F9"/>
                     </a:solidFill>
                   </a:tcPr>
                 </a:tc>
@@ -4994,7 +4994,7 @@
                       <a:pPr>
                         <a:defRPr sz="1050">
                           <a:solidFill>
-                            <a:srgbClr val="F8FAFC"/>
+                            <a:srgbClr val="0F172A"/>
                           </a:solidFill>
                         </a:defRPr>
                       </a:pPr>
@@ -5005,7 +5005,7 @@
                   </a:txBody>
                   <a:tcPr anchor="ctr">
                     <a:solidFill>
-                      <a:srgbClr val="161E2E"/>
+                      <a:srgbClr val="FFFFFF"/>
                     </a:solidFill>
                   </a:tcPr>
                 </a:tc>
@@ -5017,7 +5017,7 @@
                       <a:pPr>
                         <a:defRPr sz="1050">
                           <a:solidFill>
-                            <a:srgbClr val="EF4444"/>
+                            <a:srgbClr val="DC2626"/>
                           </a:solidFill>
                         </a:defRPr>
                       </a:pPr>
@@ -5028,7 +5028,7 @@
                   </a:txBody>
                   <a:tcPr anchor="ctr">
                     <a:solidFill>
-                      <a:srgbClr val="161E2E"/>
+                      <a:srgbClr val="FFFFFF"/>
                     </a:solidFill>
                   </a:tcPr>
                 </a:tc>
@@ -5040,7 +5040,7 @@
                       <a:pPr>
                         <a:defRPr sz="1050">
                           <a:solidFill>
-                            <a:srgbClr val="10B981"/>
+                            <a:srgbClr val="059669"/>
                           </a:solidFill>
                         </a:defRPr>
                       </a:pPr>
@@ -5051,7 +5051,7 @@
                   </a:txBody>
                   <a:tcPr anchor="ctr">
                     <a:solidFill>
-                      <a:srgbClr val="161E2E"/>
+                      <a:srgbClr val="FFFFFF"/>
                     </a:solidFill>
                   </a:tcPr>
                 </a:tc>
@@ -5063,7 +5063,7 @@
                       <a:pPr>
                         <a:defRPr sz="1050">
                           <a:solidFill>
-                            <a:srgbClr val="9CAFC9"/>
+                            <a:srgbClr val="334155"/>
                           </a:solidFill>
                         </a:defRPr>
                       </a:pPr>
@@ -5074,7 +5074,7 @@
                   </a:txBody>
                   <a:tcPr anchor="ctr">
                     <a:solidFill>
-                      <a:srgbClr val="161E2E"/>
+                      <a:srgbClr val="FFFFFF"/>
                     </a:solidFill>
                   </a:tcPr>
                 </a:tc>
@@ -5086,7 +5086,7 @@
                       <a:pPr>
                         <a:defRPr sz="1050">
                           <a:solidFill>
-                            <a:srgbClr val="9CAFC9"/>
+                            <a:srgbClr val="334155"/>
                           </a:solidFill>
                         </a:defRPr>
                       </a:pPr>
@@ -5097,7 +5097,7 @@
                   </a:txBody>
                   <a:tcPr anchor="ctr">
                     <a:solidFill>
-                      <a:srgbClr val="161E2E"/>
+                      <a:srgbClr val="FFFFFF"/>
                     </a:solidFill>
                   </a:tcPr>
                 </a:tc>
@@ -5111,7 +5111,7 @@
                       <a:pPr>
                         <a:defRPr sz="1050">
                           <a:solidFill>
-                            <a:srgbClr val="F8FAFC"/>
+                            <a:srgbClr val="0F172A"/>
                           </a:solidFill>
                         </a:defRPr>
                       </a:pPr>
@@ -5122,7 +5122,7 @@
                   </a:txBody>
                   <a:tcPr anchor="ctr">
                     <a:solidFill>
-                      <a:srgbClr val="0F172A"/>
+                      <a:srgbClr val="F8FAFC"/>
                     </a:solidFill>
                   </a:tcPr>
                 </a:tc>
@@ -5134,7 +5134,7 @@
                       <a:pPr>
                         <a:defRPr sz="1050">
                           <a:solidFill>
-                            <a:srgbClr val="9CAFC9"/>
+                            <a:srgbClr val="334155"/>
                           </a:solidFill>
                         </a:defRPr>
                       </a:pPr>
@@ -5145,7 +5145,7 @@
                   </a:txBody>
                   <a:tcPr anchor="ctr">
                     <a:solidFill>
-                      <a:srgbClr val="0F172A"/>
+                      <a:srgbClr val="F8FAFC"/>
                     </a:solidFill>
                   </a:tcPr>
                 </a:tc>
@@ -5157,7 +5157,7 @@
                       <a:pPr>
                         <a:defRPr sz="1050">
                           <a:solidFill>
-                            <a:srgbClr val="10B981"/>
+                            <a:srgbClr val="059669"/>
                           </a:solidFill>
                         </a:defRPr>
                       </a:pPr>
@@ -5168,7 +5168,7 @@
                   </a:txBody>
                   <a:tcPr anchor="ctr">
                     <a:solidFill>
-                      <a:srgbClr val="0F172A"/>
+                      <a:srgbClr val="F8FAFC"/>
                     </a:solidFill>
                   </a:tcPr>
                 </a:tc>
@@ -5180,7 +5180,7 @@
                       <a:pPr>
                         <a:defRPr sz="1050">
                           <a:solidFill>
-                            <a:srgbClr val="9CAFC9"/>
+                            <a:srgbClr val="334155"/>
                           </a:solidFill>
                         </a:defRPr>
                       </a:pPr>
@@ -5191,7 +5191,7 @@
                   </a:txBody>
                   <a:tcPr anchor="ctr">
                     <a:solidFill>
-                      <a:srgbClr val="0F172A"/>
+                      <a:srgbClr val="F8FAFC"/>
                     </a:solidFill>
                   </a:tcPr>
                 </a:tc>
@@ -5203,7 +5203,7 @@
                       <a:pPr>
                         <a:defRPr sz="1050">
                           <a:solidFill>
-                            <a:srgbClr val="9CAFC9"/>
+                            <a:srgbClr val="334155"/>
                           </a:solidFill>
                         </a:defRPr>
                       </a:pPr>
@@ -5214,7 +5214,7 @@
                   </a:txBody>
                   <a:tcPr anchor="ctr">
                     <a:solidFill>
-                      <a:srgbClr val="0F172A"/>
+                      <a:srgbClr val="F8FAFC"/>
                     </a:solidFill>
                   </a:tcPr>
                 </a:tc>
@@ -5228,7 +5228,7 @@
                       <a:pPr>
                         <a:defRPr sz="1050">
                           <a:solidFill>
-                            <a:srgbClr val="F8FAFC"/>
+                            <a:srgbClr val="0F172A"/>
                           </a:solidFill>
                         </a:defRPr>
                       </a:pPr>
@@ -5239,7 +5239,7 @@
                   </a:txBody>
                   <a:tcPr anchor="ctr">
                     <a:solidFill>
-                      <a:srgbClr val="161E2E"/>
+                      <a:srgbClr val="FFFFFF"/>
                     </a:solidFill>
                   </a:tcPr>
                 </a:tc>
@@ -5251,7 +5251,7 @@
                       <a:pPr>
                         <a:defRPr sz="1050">
                           <a:solidFill>
-                            <a:srgbClr val="EF4444"/>
+                            <a:srgbClr val="DC2626"/>
                           </a:solidFill>
                         </a:defRPr>
                       </a:pPr>
@@ -5262,7 +5262,7 @@
                   </a:txBody>
                   <a:tcPr anchor="ctr">
                     <a:solidFill>
-                      <a:srgbClr val="161E2E"/>
+                      <a:srgbClr val="FFFFFF"/>
                     </a:solidFill>
                   </a:tcPr>
                 </a:tc>
@@ -5274,7 +5274,7 @@
                       <a:pPr>
                         <a:defRPr sz="1050">
                           <a:solidFill>
-                            <a:srgbClr val="9CAFC9"/>
+                            <a:srgbClr val="334155"/>
                           </a:solidFill>
                         </a:defRPr>
                       </a:pPr>
@@ -5285,7 +5285,7 @@
                   </a:txBody>
                   <a:tcPr anchor="ctr">
                     <a:solidFill>
-                      <a:srgbClr val="161E2E"/>
+                      <a:srgbClr val="FFFFFF"/>
                     </a:solidFill>
                   </a:tcPr>
                 </a:tc>
@@ -5297,7 +5297,7 @@
                       <a:pPr>
                         <a:defRPr sz="1050">
                           <a:solidFill>
-                            <a:srgbClr val="10B981"/>
+                            <a:srgbClr val="059669"/>
                           </a:solidFill>
                         </a:defRPr>
                       </a:pPr>
@@ -5308,7 +5308,7 @@
                   </a:txBody>
                   <a:tcPr anchor="ctr">
                     <a:solidFill>
-                      <a:srgbClr val="161E2E"/>
+                      <a:srgbClr val="FFFFFF"/>
                     </a:solidFill>
                   </a:tcPr>
                 </a:tc>
@@ -5320,7 +5320,7 @@
                       <a:pPr>
                         <a:defRPr sz="1050">
                           <a:solidFill>
-                            <a:srgbClr val="9CAFC9"/>
+                            <a:srgbClr val="334155"/>
                           </a:solidFill>
                         </a:defRPr>
                       </a:pPr>
@@ -5331,7 +5331,7 @@
                   </a:txBody>
                   <a:tcPr anchor="ctr">
                     <a:solidFill>
-                      <a:srgbClr val="161E2E"/>
+                      <a:srgbClr val="FFFFFF"/>
                     </a:solidFill>
                   </a:tcPr>
                 </a:tc>
@@ -5345,7 +5345,7 @@
                       <a:pPr>
                         <a:defRPr sz="1050">
                           <a:solidFill>
-                            <a:srgbClr val="F8FAFC"/>
+                            <a:srgbClr val="0F172A"/>
                           </a:solidFill>
                         </a:defRPr>
                       </a:pPr>
@@ -5356,7 +5356,7 @@
                   </a:txBody>
                   <a:tcPr anchor="ctr">
                     <a:solidFill>
-                      <a:srgbClr val="0F172A"/>
+                      <a:srgbClr val="F8FAFC"/>
                     </a:solidFill>
                   </a:tcPr>
                 </a:tc>
@@ -5368,7 +5368,7 @@
                       <a:pPr>
                         <a:defRPr sz="1050">
                           <a:solidFill>
-                            <a:srgbClr val="9CAFC9"/>
+                            <a:srgbClr val="334155"/>
                           </a:solidFill>
                         </a:defRPr>
                       </a:pPr>
@@ -5379,7 +5379,7 @@
                   </a:txBody>
                   <a:tcPr anchor="ctr">
                     <a:solidFill>
-                      <a:srgbClr val="0F172A"/>
+                      <a:srgbClr val="F8FAFC"/>
                     </a:solidFill>
                   </a:tcPr>
                 </a:tc>
@@ -5391,7 +5391,7 @@
                       <a:pPr>
                         <a:defRPr sz="1050">
                           <a:solidFill>
-                            <a:srgbClr val="9CAFC9"/>
+                            <a:srgbClr val="334155"/>
                           </a:solidFill>
                         </a:defRPr>
                       </a:pPr>
@@ -5402,7 +5402,7 @@
                   </a:txBody>
                   <a:tcPr anchor="ctr">
                     <a:solidFill>
-                      <a:srgbClr val="0F172A"/>
+                      <a:srgbClr val="F8FAFC"/>
                     </a:solidFill>
                   </a:tcPr>
                 </a:tc>
@@ -5414,7 +5414,7 @@
                       <a:pPr>
                         <a:defRPr sz="1050">
                           <a:solidFill>
-                            <a:srgbClr val="9CAFC9"/>
+                            <a:srgbClr val="334155"/>
                           </a:solidFill>
                         </a:defRPr>
                       </a:pPr>
@@ -5425,7 +5425,7 @@
                   </a:txBody>
                   <a:tcPr anchor="ctr">
                     <a:solidFill>
-                      <a:srgbClr val="0F172A"/>
+                      <a:srgbClr val="F8FAFC"/>
                     </a:solidFill>
                   </a:tcPr>
                 </a:tc>
@@ -5437,7 +5437,7 @@
                       <a:pPr>
                         <a:defRPr sz="1050">
                           <a:solidFill>
-                            <a:srgbClr val="10B981"/>
+                            <a:srgbClr val="059669"/>
                           </a:solidFill>
                         </a:defRPr>
                       </a:pPr>
@@ -5448,7 +5448,7 @@
                   </a:txBody>
                   <a:tcPr anchor="ctr">
                     <a:solidFill>
-                      <a:srgbClr val="0F172A"/>
+                      <a:srgbClr val="F8FAFC"/>
                     </a:solidFill>
                   </a:tcPr>
                 </a:tc>
@@ -5472,11 +5472,11 @@
             <a:avLst/>
           </a:prstGeom>
           <a:solidFill>
-            <a:srgbClr val="161E2E"/>
+            <a:srgbClr val="FFFFFF"/>
           </a:solidFill>
-          <a:ln w="12700">
+          <a:ln w="15240">
             <a:solidFill>
-              <a:srgbClr val="2D3C54"/>
+              <a:srgbClr val="E2E8F0"/>
             </a:solidFill>
           </a:ln>
         </p:spPr>
@@ -5527,7 +5527,7 @@
             <a:pPr>
               <a:defRPr sz="1400" b="1">
                 <a:solidFill>
-                  <a:srgbClr val="10B981"/>
+                  <a:srgbClr val="059669"/>
                 </a:solidFill>
                 <a:latin typeface="Segoe UI"/>
               </a:defRPr>
@@ -5571,7 +5571,7 @@
             <a:r>
               <a:rPr b="1" sz="1150">
                 <a:solidFill>
-                  <a:srgbClr val="F8FAFC"/>
+                  <a:srgbClr val="0F172A"/>
                 </a:solidFill>
                 <a:latin typeface="Segoe UI"/>
               </a:rPr>
@@ -5580,7 +5580,7 @@
             <a:r>
               <a:rPr sz="1150">
                 <a:solidFill>
-                  <a:srgbClr val="9CAFC9"/>
+                  <a:srgbClr val="334155"/>
                 </a:solidFill>
                 <a:latin typeface="Segoe UI"/>
               </a:rPr>
@@ -5599,7 +5599,7 @@
             <a:r>
               <a:rPr b="1" sz="1150">
                 <a:solidFill>
-                  <a:srgbClr val="F8FAFC"/>
+                  <a:srgbClr val="0F172A"/>
                 </a:solidFill>
                 <a:latin typeface="Segoe UI"/>
               </a:rPr>
@@ -5608,7 +5608,7 @@
             <a:r>
               <a:rPr sz="1150">
                 <a:solidFill>
-                  <a:srgbClr val="9CAFC9"/>
+                  <a:srgbClr val="334155"/>
                 </a:solidFill>
                 <a:latin typeface="Segoe UI"/>
               </a:rPr>
@@ -5650,7 +5650,7 @@
             <a:avLst/>
           </a:prstGeom>
           <a:solidFill>
-            <a:srgbClr val="0B0F19"/>
+            <a:srgbClr val="F8FAFC"/>
           </a:solidFill>
           <a:ln>
             <a:noFill/>
@@ -5686,18 +5686,18 @@
         </p:nvSpPr>
         <p:spPr>
           <a:xfrm>
-            <a:off x="731520" y="365760"/>
-            <a:ext cx="2651760" cy="292608"/>
+            <a:off x="731520" y="347472"/>
+            <a:ext cx="2926080" cy="292608"/>
           </a:xfrm>
           <a:prstGeom prst="roundRect">
             <a:avLst/>
           </a:prstGeom>
           <a:solidFill>
-            <a:srgbClr val="161E2E"/>
+            <a:srgbClr val="FEF2F2"/>
           </a:solidFill>
           <a:ln w="12700">
             <a:solidFill>
-              <a:srgbClr val="EF4444"/>
+              <a:srgbClr val="FECACA"/>
             </a:solidFill>
           </a:ln>
         </p:spPr>
@@ -5722,7 +5722,7 @@
             <a:pPr algn="ctr">
               <a:defRPr sz="1000" b="1">
                 <a:solidFill>
-                  <a:srgbClr val="EF4444"/>
+                  <a:srgbClr val="DC2626"/>
                 </a:solidFill>
                 <a:latin typeface="Segoe UI"/>
               </a:defRPr>
@@ -5741,7 +5741,7 @@
         </p:nvSpPr>
         <p:spPr>
           <a:xfrm>
-            <a:off x="731520" y="713232"/>
+            <a:off x="731520" y="694944"/>
             <a:ext cx="10698480" cy="594360"/>
           </a:xfrm>
           <a:prstGeom prst="rect">
@@ -5758,7 +5758,7 @@
             <a:pPr>
               <a:defRPr sz="2400" b="1">
                 <a:solidFill>
-                  <a:srgbClr val="F8FAFC"/>
+                  <a:srgbClr val="0F172A"/>
                 </a:solidFill>
                 <a:latin typeface="Segoe UI"/>
               </a:defRPr>
@@ -5784,11 +5784,11 @@
             <a:avLst/>
           </a:prstGeom>
           <a:solidFill>
-            <a:srgbClr val="161E2E"/>
+            <a:srgbClr val="FFFFFF"/>
           </a:solidFill>
-          <a:ln w="12700">
+          <a:ln w="15240">
             <a:solidFill>
-              <a:srgbClr val="2D3C54"/>
+              <a:srgbClr val="E2E8F0"/>
             </a:solidFill>
           </a:ln>
         </p:spPr>
@@ -5839,7 +5839,7 @@
             <a:pPr>
               <a:defRPr sz="1400" b="1">
                 <a:solidFill>
-                  <a:srgbClr val="EF4444"/>
+                  <a:srgbClr val="DC2626"/>
                 </a:solidFill>
                 <a:latin typeface="Segoe UI"/>
               </a:defRPr>
@@ -5883,7 +5883,7 @@
             <a:r>
               <a:rPr b="1" sz="1200">
                 <a:solidFill>
-                  <a:srgbClr val="F8FAFC"/>
+                  <a:srgbClr val="0F172A"/>
                 </a:solidFill>
                 <a:latin typeface="Segoe UI"/>
               </a:rPr>
@@ -5892,7 +5892,7 @@
             <a:r>
               <a:rPr sz="1200">
                 <a:solidFill>
-                  <a:srgbClr val="9CAFC9"/>
+                  <a:srgbClr val="334155"/>
                 </a:solidFill>
                 <a:latin typeface="Segoe UI"/>
               </a:rPr>
@@ -5911,7 +5911,7 @@
             <a:r>
               <a:rPr b="1" sz="1200">
                 <a:solidFill>
-                  <a:srgbClr val="F8FAFC"/>
+                  <a:srgbClr val="0F172A"/>
                 </a:solidFill>
                 <a:latin typeface="Segoe UI"/>
               </a:rPr>
@@ -5920,7 +5920,7 @@
             <a:r>
               <a:rPr sz="1200">
                 <a:solidFill>
-                  <a:srgbClr val="9CAFC9"/>
+                  <a:srgbClr val="334155"/>
                 </a:solidFill>
                 <a:latin typeface="Segoe UI"/>
               </a:rPr>
@@ -5939,7 +5939,7 @@
             <a:r>
               <a:rPr b="1" sz="1200">
                 <a:solidFill>
-                  <a:srgbClr val="F8FAFC"/>
+                  <a:srgbClr val="0F172A"/>
                 </a:solidFill>
                 <a:latin typeface="Segoe UI"/>
               </a:rPr>
@@ -5948,7 +5948,7 @@
             <a:r>
               <a:rPr sz="1200">
                 <a:solidFill>
-                  <a:srgbClr val="9CAFC9"/>
+                  <a:srgbClr val="334155"/>
                 </a:solidFill>
                 <a:latin typeface="Segoe UI"/>
               </a:rPr>
@@ -5967,7 +5967,7 @@
             <a:r>
               <a:rPr b="1" sz="1200">
                 <a:solidFill>
-                  <a:srgbClr val="F8FAFC"/>
+                  <a:srgbClr val="0F172A"/>
                 </a:solidFill>
                 <a:latin typeface="Segoe UI"/>
               </a:rPr>
@@ -5976,7 +5976,7 @@
             <a:r>
               <a:rPr sz="1200">
                 <a:solidFill>
-                  <a:srgbClr val="9CAFC9"/>
+                  <a:srgbClr val="334155"/>
                 </a:solidFill>
                 <a:latin typeface="Segoe UI"/>
               </a:rPr>
@@ -6000,11 +6000,11 @@
             <a:avLst/>
           </a:prstGeom>
           <a:solidFill>
-            <a:srgbClr val="161E2E"/>
+            <a:srgbClr val="FFFFFF"/>
           </a:solidFill>
-          <a:ln w="12700">
+          <a:ln w="15240">
             <a:solidFill>
-              <a:srgbClr val="2D3C54"/>
+              <a:srgbClr val="E2E8F0"/>
             </a:solidFill>
           </a:ln>
         </p:spPr>
@@ -6055,7 +6055,7 @@
             <a:pPr>
               <a:defRPr sz="1400" b="1">
                 <a:solidFill>
-                  <a:srgbClr val="06B6D4"/>
+                  <a:srgbClr val="0284C7"/>
                 </a:solidFill>
                 <a:latin typeface="Segoe UI"/>
               </a:defRPr>
@@ -6099,7 +6099,7 @@
             <a:r>
               <a:rPr b="1" sz="1200">
                 <a:solidFill>
-                  <a:srgbClr val="F8FAFC"/>
+                  <a:srgbClr val="0F172A"/>
                 </a:solidFill>
                 <a:latin typeface="Segoe UI"/>
               </a:rPr>
@@ -6108,7 +6108,7 @@
             <a:r>
               <a:rPr sz="1200">
                 <a:solidFill>
-                  <a:srgbClr val="9CAFC9"/>
+                  <a:srgbClr val="334155"/>
                 </a:solidFill>
                 <a:latin typeface="Segoe UI"/>
               </a:rPr>
@@ -6127,7 +6127,7 @@
             <a:r>
               <a:rPr b="1" sz="1200">
                 <a:solidFill>
-                  <a:srgbClr val="F8FAFC"/>
+                  <a:srgbClr val="0F172A"/>
                 </a:solidFill>
                 <a:latin typeface="Segoe UI"/>
               </a:rPr>
@@ -6136,7 +6136,7 @@
             <a:r>
               <a:rPr sz="1200">
                 <a:solidFill>
-                  <a:srgbClr val="9CAFC9"/>
+                  <a:srgbClr val="334155"/>
                 </a:solidFill>
                 <a:latin typeface="Segoe UI"/>
               </a:rPr>
@@ -6155,7 +6155,7 @@
             <a:r>
               <a:rPr b="1" sz="1200">
                 <a:solidFill>
-                  <a:srgbClr val="F8FAFC"/>
+                  <a:srgbClr val="0F172A"/>
                 </a:solidFill>
                 <a:latin typeface="Segoe UI"/>
               </a:rPr>
@@ -6164,7 +6164,7 @@
             <a:r>
               <a:rPr sz="1200">
                 <a:solidFill>
-                  <a:srgbClr val="9CAFC9"/>
+                  <a:srgbClr val="334155"/>
                 </a:solidFill>
                 <a:latin typeface="Segoe UI"/>
               </a:rPr>
@@ -6183,7 +6183,7 @@
             <a:r>
               <a:rPr b="1" sz="1200">
                 <a:solidFill>
-                  <a:srgbClr val="F8FAFC"/>
+                  <a:srgbClr val="0F172A"/>
                 </a:solidFill>
                 <a:latin typeface="Segoe UI"/>
               </a:rPr>
@@ -6192,7 +6192,7 @@
             <a:r>
               <a:rPr sz="1200">
                 <a:solidFill>
-                  <a:srgbClr val="9CAFC9"/>
+                  <a:srgbClr val="334155"/>
                 </a:solidFill>
                 <a:latin typeface="Segoe UI"/>
               </a:rPr>
@@ -6234,7 +6234,7 @@
             <a:avLst/>
           </a:prstGeom>
           <a:solidFill>
-            <a:srgbClr val="0B0F19"/>
+            <a:srgbClr val="F8FAFC"/>
           </a:solidFill>
           <a:ln>
             <a:noFill/>
@@ -6270,18 +6270,18 @@
         </p:nvSpPr>
         <p:spPr>
           <a:xfrm>
-            <a:off x="731520" y="365760"/>
-            <a:ext cx="2651760" cy="292608"/>
+            <a:off x="731520" y="347472"/>
+            <a:ext cx="2926080" cy="292608"/>
           </a:xfrm>
           <a:prstGeom prst="roundRect">
             <a:avLst/>
           </a:prstGeom>
           <a:solidFill>
-            <a:srgbClr val="161E2E"/>
+            <a:srgbClr val="EFF6FF"/>
           </a:solidFill>
           <a:ln w="12700">
             <a:solidFill>
-              <a:srgbClr val="06B6D4"/>
+              <a:srgbClr val="BFDBFE"/>
             </a:solidFill>
           </a:ln>
         </p:spPr>
@@ -6306,7 +6306,7 @@
             <a:pPr algn="ctr">
               <a:defRPr sz="1000" b="1">
                 <a:solidFill>
-                  <a:srgbClr val="06B6D4"/>
+                  <a:srgbClr val="0284C7"/>
                 </a:solidFill>
                 <a:latin typeface="Segoe UI"/>
               </a:defRPr>
@@ -6325,7 +6325,7 @@
         </p:nvSpPr>
         <p:spPr>
           <a:xfrm>
-            <a:off x="731520" y="713232"/>
+            <a:off x="731520" y="694944"/>
             <a:ext cx="10698480" cy="594360"/>
           </a:xfrm>
           <a:prstGeom prst="rect">
@@ -6342,7 +6342,7 @@
             <a:pPr>
               <a:defRPr sz="2400" b="1">
                 <a:solidFill>
-                  <a:srgbClr val="F8FAFC"/>
+                  <a:srgbClr val="0F172A"/>
                 </a:solidFill>
                 <a:latin typeface="Segoe UI"/>
               </a:defRPr>
@@ -6368,11 +6368,11 @@
             <a:avLst/>
           </a:prstGeom>
           <a:solidFill>
-            <a:srgbClr val="161E2E"/>
+            <a:srgbClr val="FFFFFF"/>
           </a:solidFill>
-          <a:ln w="12700">
+          <a:ln w="15240">
             <a:solidFill>
-              <a:srgbClr val="2D3C54"/>
+              <a:srgbClr val="E2E8F0"/>
             </a:solidFill>
           </a:ln>
         </p:spPr>
@@ -6423,7 +6423,7 @@
             <a:pPr>
               <a:defRPr sz="1400" b="1">
                 <a:solidFill>
-                  <a:srgbClr val="EF4444"/>
+                  <a:srgbClr val="DC2626"/>
                 </a:solidFill>
                 <a:latin typeface="Segoe UI"/>
               </a:defRPr>
@@ -6467,7 +6467,7 @@
             <a:r>
               <a:rPr b="1" sz="1200">
                 <a:solidFill>
-                  <a:srgbClr val="F8FAFC"/>
+                  <a:srgbClr val="0F172A"/>
                 </a:solidFill>
                 <a:latin typeface="Segoe UI"/>
               </a:rPr>
@@ -6476,7 +6476,7 @@
             <a:r>
               <a:rPr sz="1200">
                 <a:solidFill>
-                  <a:srgbClr val="9CAFC9"/>
+                  <a:srgbClr val="334155"/>
                 </a:solidFill>
                 <a:latin typeface="Segoe UI"/>
               </a:rPr>
@@ -6495,7 +6495,7 @@
             <a:r>
               <a:rPr b="1" sz="1200">
                 <a:solidFill>
-                  <a:srgbClr val="F8FAFC"/>
+                  <a:srgbClr val="0F172A"/>
                 </a:solidFill>
                 <a:latin typeface="Segoe UI"/>
               </a:rPr>
@@ -6504,7 +6504,7 @@
             <a:r>
               <a:rPr sz="1200">
                 <a:solidFill>
-                  <a:srgbClr val="9CAFC9"/>
+                  <a:srgbClr val="334155"/>
                 </a:solidFill>
                 <a:latin typeface="Segoe UI"/>
               </a:rPr>
@@ -6523,7 +6523,7 @@
             <a:r>
               <a:rPr b="1" sz="1200">
                 <a:solidFill>
-                  <a:srgbClr val="F8FAFC"/>
+                  <a:srgbClr val="0F172A"/>
                 </a:solidFill>
                 <a:latin typeface="Segoe UI"/>
               </a:rPr>
@@ -6532,7 +6532,7 @@
             <a:r>
               <a:rPr sz="1200">
                 <a:solidFill>
-                  <a:srgbClr val="9CAFC9"/>
+                  <a:srgbClr val="334155"/>
                 </a:solidFill>
                 <a:latin typeface="Segoe UI"/>
               </a:rPr>
@@ -6551,7 +6551,7 @@
             <a:r>
               <a:rPr b="1" sz="1200">
                 <a:solidFill>
-                  <a:srgbClr val="F8FAFC"/>
+                  <a:srgbClr val="0F172A"/>
                 </a:solidFill>
                 <a:latin typeface="Segoe UI"/>
               </a:rPr>
@@ -6560,7 +6560,7 @@
             <a:r>
               <a:rPr sz="1200">
                 <a:solidFill>
-                  <a:srgbClr val="9CAFC9"/>
+                  <a:srgbClr val="334155"/>
                 </a:solidFill>
                 <a:latin typeface="Segoe UI"/>
               </a:rPr>
@@ -6584,11 +6584,11 @@
             <a:avLst/>
           </a:prstGeom>
           <a:solidFill>
-            <a:srgbClr val="161E2E"/>
+            <a:srgbClr val="FFFFFF"/>
           </a:solidFill>
-          <a:ln w="12700">
+          <a:ln w="15240">
             <a:solidFill>
-              <a:srgbClr val="2D3C54"/>
+              <a:srgbClr val="E2E8F0"/>
             </a:solidFill>
           </a:ln>
         </p:spPr>
@@ -6639,7 +6639,7 @@
             <a:pPr>
               <a:defRPr sz="1400" b="1">
                 <a:solidFill>
-                  <a:srgbClr val="10B981"/>
+                  <a:srgbClr val="059669"/>
                 </a:solidFill>
                 <a:latin typeface="Segoe UI"/>
               </a:defRPr>
@@ -6683,7 +6683,7 @@
             <a:r>
               <a:rPr b="1" sz="1200">
                 <a:solidFill>
-                  <a:srgbClr val="F8FAFC"/>
+                  <a:srgbClr val="0F172A"/>
                 </a:solidFill>
                 <a:latin typeface="Segoe UI"/>
               </a:rPr>
@@ -6692,7 +6692,7 @@
             <a:r>
               <a:rPr sz="1200">
                 <a:solidFill>
-                  <a:srgbClr val="9CAFC9"/>
+                  <a:srgbClr val="334155"/>
                 </a:solidFill>
                 <a:latin typeface="Segoe UI"/>
               </a:rPr>
@@ -6711,7 +6711,7 @@
             <a:r>
               <a:rPr b="1" sz="1200">
                 <a:solidFill>
-                  <a:srgbClr val="F8FAFC"/>
+                  <a:srgbClr val="0F172A"/>
                 </a:solidFill>
                 <a:latin typeface="Segoe UI"/>
               </a:rPr>
@@ -6720,7 +6720,7 @@
             <a:r>
               <a:rPr sz="1200">
                 <a:solidFill>
-                  <a:srgbClr val="9CAFC9"/>
+                  <a:srgbClr val="334155"/>
                 </a:solidFill>
                 <a:latin typeface="Segoe UI"/>
               </a:rPr>
@@ -6739,7 +6739,7 @@
             <a:r>
               <a:rPr b="1" sz="1200">
                 <a:solidFill>
-                  <a:srgbClr val="F8FAFC"/>
+                  <a:srgbClr val="0F172A"/>
                 </a:solidFill>
                 <a:latin typeface="Segoe UI"/>
               </a:rPr>
@@ -6748,7 +6748,7 @@
             <a:r>
               <a:rPr sz="1200">
                 <a:solidFill>
-                  <a:srgbClr val="9CAFC9"/>
+                  <a:srgbClr val="334155"/>
                 </a:solidFill>
                 <a:latin typeface="Segoe UI"/>
               </a:rPr>
@@ -6767,7 +6767,7 @@
             <a:r>
               <a:rPr b="1" sz="1200">
                 <a:solidFill>
-                  <a:srgbClr val="F8FAFC"/>
+                  <a:srgbClr val="0F172A"/>
                 </a:solidFill>
                 <a:latin typeface="Segoe UI"/>
               </a:rPr>
@@ -6776,7 +6776,7 @@
             <a:r>
               <a:rPr sz="1200">
                 <a:solidFill>
-                  <a:srgbClr val="9CAFC9"/>
+                  <a:srgbClr val="334155"/>
                 </a:solidFill>
                 <a:latin typeface="Segoe UI"/>
               </a:rPr>
@@ -6818,7 +6818,7 @@
             <a:avLst/>
           </a:prstGeom>
           <a:solidFill>
-            <a:srgbClr val="0B0F19"/>
+            <a:srgbClr val="F8FAFC"/>
           </a:solidFill>
           <a:ln>
             <a:noFill/>
@@ -6854,18 +6854,18 @@
         </p:nvSpPr>
         <p:spPr>
           <a:xfrm>
-            <a:off x="731520" y="365760"/>
-            <a:ext cx="2651760" cy="292608"/>
+            <a:off x="731520" y="347472"/>
+            <a:ext cx="2926080" cy="292608"/>
           </a:xfrm>
           <a:prstGeom prst="roundRect">
             <a:avLst/>
           </a:prstGeom>
           <a:solidFill>
-            <a:srgbClr val="161E2E"/>
+            <a:srgbClr val="ECFDF5"/>
           </a:solidFill>
           <a:ln w="12700">
             <a:solidFill>
-              <a:srgbClr val="10B981"/>
+              <a:srgbClr val="A7F3D0"/>
             </a:solidFill>
           </a:ln>
         </p:spPr>
@@ -6890,7 +6890,7 @@
             <a:pPr algn="ctr">
               <a:defRPr sz="1000" b="1">
                 <a:solidFill>
-                  <a:srgbClr val="10B981"/>
+                  <a:srgbClr val="059669"/>
                 </a:solidFill>
                 <a:latin typeface="Segoe UI"/>
               </a:defRPr>
@@ -6909,7 +6909,7 @@
         </p:nvSpPr>
         <p:spPr>
           <a:xfrm>
-            <a:off x="731520" y="713232"/>
+            <a:off x="731520" y="694944"/>
             <a:ext cx="10698480" cy="594360"/>
           </a:xfrm>
           <a:prstGeom prst="rect">
@@ -6926,7 +6926,7 @@
             <a:pPr>
               <a:defRPr sz="2400" b="1">
                 <a:solidFill>
-                  <a:srgbClr val="F8FAFC"/>
+                  <a:srgbClr val="0F172A"/>
                 </a:solidFill>
                 <a:latin typeface="Segoe UI"/>
               </a:defRPr>
@@ -6952,11 +6952,11 @@
             <a:avLst/>
           </a:prstGeom>
           <a:solidFill>
-            <a:srgbClr val="161E2E"/>
+            <a:srgbClr val="FFFFFF"/>
           </a:solidFill>
-          <a:ln w="12700">
+          <a:ln w="15240">
             <a:solidFill>
-              <a:srgbClr val="2D3C54"/>
+              <a:srgbClr val="E2E8F0"/>
             </a:solidFill>
           </a:ln>
         </p:spPr>
@@ -7007,7 +7007,7 @@
             <a:pPr>
               <a:defRPr sz="1400" b="1">
                 <a:solidFill>
-                  <a:srgbClr val="10B981"/>
+                  <a:srgbClr val="059669"/>
                 </a:solidFill>
                 <a:latin typeface="Segoe UI"/>
               </a:defRPr>
@@ -7051,7 +7051,7 @@
             <a:r>
               <a:rPr b="1" sz="1200">
                 <a:solidFill>
-                  <a:srgbClr val="F8FAFC"/>
+                  <a:srgbClr val="0F172A"/>
                 </a:solidFill>
                 <a:latin typeface="Segoe UI"/>
               </a:rPr>
@@ -7060,7 +7060,7 @@
             <a:r>
               <a:rPr sz="1200">
                 <a:solidFill>
-                  <a:srgbClr val="9CAFC9"/>
+                  <a:srgbClr val="334155"/>
                 </a:solidFill>
                 <a:latin typeface="Segoe UI"/>
               </a:rPr>
@@ -7079,7 +7079,7 @@
             <a:r>
               <a:rPr b="1" sz="1200">
                 <a:solidFill>
-                  <a:srgbClr val="F8FAFC"/>
+                  <a:srgbClr val="0F172A"/>
                 </a:solidFill>
                 <a:latin typeface="Segoe UI"/>
               </a:rPr>
@@ -7088,7 +7088,7 @@
             <a:r>
               <a:rPr sz="1200">
                 <a:solidFill>
-                  <a:srgbClr val="9CAFC9"/>
+                  <a:srgbClr val="334155"/>
                 </a:solidFill>
                 <a:latin typeface="Segoe UI"/>
               </a:rPr>
@@ -7108,7 +7108,7 @@
             <a:r>
               <a:rPr b="1" sz="1200">
                 <a:solidFill>
-                  <a:srgbClr val="F8FAFC"/>
+                  <a:srgbClr val="0F172A"/>
                 </a:solidFill>
                 <a:latin typeface="Segoe UI"/>
               </a:rPr>
@@ -7117,7 +7117,7 @@
             <a:r>
               <a:rPr sz="1200">
                 <a:solidFill>
-                  <a:srgbClr val="9CAFC9"/>
+                  <a:srgbClr val="334155"/>
                 </a:solidFill>
                 <a:latin typeface="Segoe UI"/>
               </a:rPr>
@@ -7136,7 +7136,7 @@
             <a:r>
               <a:rPr b="1" sz="1200">
                 <a:solidFill>
-                  <a:srgbClr val="F8FAFC"/>
+                  <a:srgbClr val="0F172A"/>
                 </a:solidFill>
                 <a:latin typeface="Segoe UI"/>
               </a:rPr>
@@ -7145,7 +7145,7 @@
             <a:r>
               <a:rPr sz="1200">
                 <a:solidFill>
-                  <a:srgbClr val="9CAFC9"/>
+                  <a:srgbClr val="334155"/>
                 </a:solidFill>
                 <a:latin typeface="Segoe UI"/>
               </a:rPr>
@@ -7169,11 +7169,11 @@
             <a:avLst/>
           </a:prstGeom>
           <a:solidFill>
-            <a:srgbClr val="161E2E"/>
+            <a:srgbClr val="FFFFFF"/>
           </a:solidFill>
-          <a:ln w="12700">
+          <a:ln w="15240">
             <a:solidFill>
-              <a:srgbClr val="2D3C54"/>
+              <a:srgbClr val="E2E8F0"/>
             </a:solidFill>
           </a:ln>
         </p:spPr>
@@ -7224,7 +7224,7 @@
             <a:pPr>
               <a:defRPr sz="1400" b="1">
                 <a:solidFill>
-                  <a:srgbClr val="06B6D4"/>
+                  <a:srgbClr val="0284C7"/>
                 </a:solidFill>
                 <a:latin typeface="Segoe UI"/>
               </a:defRPr>
@@ -7250,11 +7250,11 @@
             <a:avLst/>
           </a:prstGeom>
           <a:solidFill>
-            <a:srgbClr val="0F172A"/>
+            <a:srgbClr val="F1F5F9"/>
           </a:solidFill>
-          <a:ln w="12700">
+          <a:ln w="15240">
             <a:solidFill>
-              <a:srgbClr val="334155"/>
+              <a:srgbClr val="CBD5E1"/>
             </a:solidFill>
           </a:ln>
         </p:spPr>
@@ -7305,7 +7305,7 @@
             <a:pPr>
               <a:defRPr sz="1050">
                 <a:solidFill>
-                  <a:srgbClr val="38BDF8"/>
+                  <a:srgbClr val="0F172A"/>
                 </a:solidFill>
                 <a:latin typeface="Consolas"/>
               </a:defRPr>
@@ -7409,7 +7409,7 @@
             <a:avLst/>
           </a:prstGeom>
           <a:solidFill>
-            <a:srgbClr val="0B0F19"/>
+            <a:srgbClr val="F8FAFC"/>
           </a:solidFill>
           <a:ln>
             <a:noFill/>
@@ -7445,18 +7445,18 @@
         </p:nvSpPr>
         <p:spPr>
           <a:xfrm>
-            <a:off x="731520" y="365760"/>
-            <a:ext cx="2651760" cy="292608"/>
+            <a:off x="731520" y="347472"/>
+            <a:ext cx="2926080" cy="292608"/>
           </a:xfrm>
           <a:prstGeom prst="roundRect">
             <a:avLst/>
           </a:prstGeom>
           <a:solidFill>
-            <a:srgbClr val="161E2E"/>
+            <a:srgbClr val="ECFDF5"/>
           </a:solidFill>
           <a:ln w="12700">
             <a:solidFill>
-              <a:srgbClr val="10B981"/>
+              <a:srgbClr val="A7F3D0"/>
             </a:solidFill>
           </a:ln>
         </p:spPr>
@@ -7481,7 +7481,7 @@
             <a:pPr algn="ctr">
               <a:defRPr sz="1000" b="1">
                 <a:solidFill>
-                  <a:srgbClr val="10B981"/>
+                  <a:srgbClr val="059669"/>
                 </a:solidFill>
                 <a:latin typeface="Segoe UI"/>
               </a:defRPr>
@@ -7500,7 +7500,7 @@
         </p:nvSpPr>
         <p:spPr>
           <a:xfrm>
-            <a:off x="731520" y="713232"/>
+            <a:off x="731520" y="694944"/>
             <a:ext cx="10698480" cy="594360"/>
           </a:xfrm>
           <a:prstGeom prst="rect">
@@ -7517,7 +7517,7 @@
             <a:pPr>
               <a:defRPr sz="2400" b="1">
                 <a:solidFill>
-                  <a:srgbClr val="F8FAFC"/>
+                  <a:srgbClr val="0F172A"/>
                 </a:solidFill>
                 <a:latin typeface="Segoe UI"/>
               </a:defRPr>
@@ -7543,11 +7543,11 @@
             <a:avLst/>
           </a:prstGeom>
           <a:solidFill>
-            <a:srgbClr val="161E2E"/>
+            <a:srgbClr val="FFFFFF"/>
           </a:solidFill>
-          <a:ln w="12700">
+          <a:ln w="15240">
             <a:solidFill>
-              <a:srgbClr val="2D3C54"/>
+              <a:srgbClr val="E2E8F0"/>
             </a:solidFill>
           </a:ln>
         </p:spPr>
@@ -7598,7 +7598,7 @@
             <a:pPr>
               <a:defRPr sz="1400" b="1">
                 <a:solidFill>
-                  <a:srgbClr val="10B981"/>
+                  <a:srgbClr val="059669"/>
                 </a:solidFill>
                 <a:latin typeface="Segoe UI"/>
               </a:defRPr>
@@ -7642,7 +7642,7 @@
             <a:r>
               <a:rPr b="1" sz="1200">
                 <a:solidFill>
-                  <a:srgbClr val="F8FAFC"/>
+                  <a:srgbClr val="0F172A"/>
                 </a:solidFill>
                 <a:latin typeface="Segoe UI"/>
               </a:rPr>
@@ -7651,7 +7651,7 @@
             <a:r>
               <a:rPr sz="1200">
                 <a:solidFill>
-                  <a:srgbClr val="9CAFC9"/>
+                  <a:srgbClr val="334155"/>
                 </a:solidFill>
                 <a:latin typeface="Segoe UI"/>
               </a:rPr>
@@ -7670,7 +7670,7 @@
             <a:r>
               <a:rPr b="1" sz="1200">
                 <a:solidFill>
-                  <a:srgbClr val="F8FAFC"/>
+                  <a:srgbClr val="0F172A"/>
                 </a:solidFill>
                 <a:latin typeface="Segoe UI"/>
               </a:rPr>
@@ -7679,7 +7679,7 @@
             <a:r>
               <a:rPr sz="1200">
                 <a:solidFill>
-                  <a:srgbClr val="9CAFC9"/>
+                  <a:srgbClr val="334155"/>
                 </a:solidFill>
                 <a:latin typeface="Segoe UI"/>
               </a:rPr>
@@ -7698,7 +7698,7 @@
             <a:r>
               <a:rPr b="1" sz="1200">
                 <a:solidFill>
-                  <a:srgbClr val="F8FAFC"/>
+                  <a:srgbClr val="0F172A"/>
                 </a:solidFill>
                 <a:latin typeface="Segoe UI"/>
               </a:rPr>
@@ -7707,7 +7707,7 @@
             <a:r>
               <a:rPr sz="1200">
                 <a:solidFill>
-                  <a:srgbClr val="9CAFC9"/>
+                  <a:srgbClr val="334155"/>
                 </a:solidFill>
                 <a:latin typeface="Segoe UI"/>
               </a:rPr>
@@ -7726,7 +7726,7 @@
             <a:r>
               <a:rPr b="1" sz="1200">
                 <a:solidFill>
-                  <a:srgbClr val="F8FAFC"/>
+                  <a:srgbClr val="0F172A"/>
                 </a:solidFill>
                 <a:latin typeface="Segoe UI"/>
               </a:rPr>
@@ -7735,7 +7735,7 @@
             <a:r>
               <a:rPr sz="1200">
                 <a:solidFill>
-                  <a:srgbClr val="9CAFC9"/>
+                  <a:srgbClr val="334155"/>
                 </a:solidFill>
                 <a:latin typeface="Segoe UI"/>
               </a:rPr>
@@ -7759,11 +7759,11 @@
             <a:avLst/>
           </a:prstGeom>
           <a:solidFill>
-            <a:srgbClr val="161E2E"/>
+            <a:srgbClr val="FFFFFF"/>
           </a:solidFill>
-          <a:ln w="12700">
+          <a:ln w="15240">
             <a:solidFill>
-              <a:srgbClr val="2D3C54"/>
+              <a:srgbClr val="E2E8F0"/>
             </a:solidFill>
           </a:ln>
         </p:spPr>
@@ -7814,7 +7814,7 @@
             <a:pPr>
               <a:defRPr sz="1400" b="1">
                 <a:solidFill>
-                  <a:srgbClr val="06B6D4"/>
+                  <a:srgbClr val="0284C7"/>
                 </a:solidFill>
                 <a:latin typeface="Segoe UI"/>
               </a:defRPr>
@@ -7840,11 +7840,11 @@
             <a:avLst/>
           </a:prstGeom>
           <a:solidFill>
-            <a:srgbClr val="0F172A"/>
+            <a:srgbClr val="F1F5F9"/>
           </a:solidFill>
-          <a:ln w="12700">
+          <a:ln w="15240">
             <a:solidFill>
-              <a:srgbClr val="334155"/>
+              <a:srgbClr val="CBD5E1"/>
             </a:solidFill>
           </a:ln>
         </p:spPr>
@@ -7895,7 +7895,7 @@
             <a:pPr>
               <a:defRPr sz="1050">
                 <a:solidFill>
-                  <a:srgbClr val="38BDF8"/>
+                  <a:srgbClr val="0F172A"/>
                 </a:solidFill>
                 <a:latin typeface="Consolas"/>
               </a:defRPr>
@@ -8007,7 +8007,7 @@
             <a:avLst/>
           </a:prstGeom>
           <a:solidFill>
-            <a:srgbClr val="0B0F19"/>
+            <a:srgbClr val="F8FAFC"/>
           </a:solidFill>
           <a:ln>
             <a:noFill/>
@@ -8043,18 +8043,18 @@
         </p:nvSpPr>
         <p:spPr>
           <a:xfrm>
-            <a:off x="731520" y="365760"/>
-            <a:ext cx="2651760" cy="292608"/>
+            <a:off x="731520" y="347472"/>
+            <a:ext cx="2926080" cy="292608"/>
           </a:xfrm>
           <a:prstGeom prst="roundRect">
             <a:avLst/>
           </a:prstGeom>
           <a:solidFill>
-            <a:srgbClr val="161E2E"/>
+            <a:srgbClr val="ECFDF5"/>
           </a:solidFill>
           <a:ln w="12700">
             <a:solidFill>
-              <a:srgbClr val="10B981"/>
+              <a:srgbClr val="A7F3D0"/>
             </a:solidFill>
           </a:ln>
         </p:spPr>
@@ -8079,7 +8079,7 @@
             <a:pPr algn="ctr">
               <a:defRPr sz="1000" b="1">
                 <a:solidFill>
-                  <a:srgbClr val="10B981"/>
+                  <a:srgbClr val="059669"/>
                 </a:solidFill>
                 <a:latin typeface="Segoe UI"/>
               </a:defRPr>
@@ -8098,7 +8098,7 @@
         </p:nvSpPr>
         <p:spPr>
           <a:xfrm>
-            <a:off x="731520" y="713232"/>
+            <a:off x="731520" y="694944"/>
             <a:ext cx="10698480" cy="594360"/>
           </a:xfrm>
           <a:prstGeom prst="rect">
@@ -8115,7 +8115,7 @@
             <a:pPr>
               <a:defRPr sz="2400" b="1">
                 <a:solidFill>
-                  <a:srgbClr val="F8FAFC"/>
+                  <a:srgbClr val="0F172A"/>
                 </a:solidFill>
                 <a:latin typeface="Segoe UI"/>
               </a:defRPr>
@@ -8141,11 +8141,11 @@
             <a:avLst/>
           </a:prstGeom>
           <a:solidFill>
-            <a:srgbClr val="161E2E"/>
+            <a:srgbClr val="FFFFFF"/>
           </a:solidFill>
-          <a:ln w="12700">
+          <a:ln w="15240">
             <a:solidFill>
-              <a:srgbClr val="2D3C54"/>
+              <a:srgbClr val="E2E8F0"/>
             </a:solidFill>
           </a:ln>
         </p:spPr>
@@ -8196,7 +8196,7 @@
             <a:pPr>
               <a:defRPr sz="1400" b="1">
                 <a:solidFill>
-                  <a:srgbClr val="10B981"/>
+                  <a:srgbClr val="059669"/>
                 </a:solidFill>
                 <a:latin typeface="Segoe UI"/>
               </a:defRPr>
@@ -8240,7 +8240,7 @@
             <a:r>
               <a:rPr b="1" sz="1150">
                 <a:solidFill>
-                  <a:srgbClr val="F8FAFC"/>
+                  <a:srgbClr val="0F172A"/>
                 </a:solidFill>
                 <a:latin typeface="Segoe UI"/>
               </a:rPr>
@@ -8249,7 +8249,7 @@
             <a:r>
               <a:rPr sz="1150">
                 <a:solidFill>
-                  <a:srgbClr val="9CAFC9"/>
+                  <a:srgbClr val="334155"/>
                 </a:solidFill>
                 <a:latin typeface="Segoe UI"/>
               </a:rPr>
@@ -8268,7 +8268,7 @@
             <a:r>
               <a:rPr b="1" sz="1150">
                 <a:solidFill>
-                  <a:srgbClr val="F8FAFC"/>
+                  <a:srgbClr val="0F172A"/>
                 </a:solidFill>
                 <a:latin typeface="Segoe UI"/>
               </a:rPr>
@@ -8277,7 +8277,7 @@
             <a:r>
               <a:rPr sz="1150">
                 <a:solidFill>
-                  <a:srgbClr val="9CAFC9"/>
+                  <a:srgbClr val="334155"/>
                 </a:solidFill>
                 <a:latin typeface="Segoe UI"/>
               </a:rPr>
@@ -8296,7 +8296,7 @@
             <a:r>
               <a:rPr b="1" sz="1150">
                 <a:solidFill>
-                  <a:srgbClr val="F8FAFC"/>
+                  <a:srgbClr val="0F172A"/>
                 </a:solidFill>
                 <a:latin typeface="Segoe UI"/>
               </a:rPr>
@@ -8305,7 +8305,7 @@
             <a:r>
               <a:rPr sz="1150">
                 <a:solidFill>
-                  <a:srgbClr val="9CAFC9"/>
+                  <a:srgbClr val="334155"/>
                 </a:solidFill>
                 <a:latin typeface="Segoe UI"/>
               </a:rPr>
@@ -8329,11 +8329,11 @@
             <a:avLst/>
           </a:prstGeom>
           <a:solidFill>
-            <a:srgbClr val="161E2E"/>
+            <a:srgbClr val="FFFFFF"/>
           </a:solidFill>
-          <a:ln w="12700">
+          <a:ln w="15240">
             <a:solidFill>
-              <a:srgbClr val="2D3C54"/>
+              <a:srgbClr val="E2E8F0"/>
             </a:solidFill>
           </a:ln>
         </p:spPr>
@@ -8384,7 +8384,7 @@
             <a:pPr>
               <a:defRPr sz="1400" b="1">
                 <a:solidFill>
-                  <a:srgbClr val="06B6D4"/>
+                  <a:srgbClr val="0284C7"/>
                 </a:solidFill>
                 <a:latin typeface="Segoe UI"/>
               </a:defRPr>
@@ -8428,7 +8428,7 @@
             <a:r>
               <a:rPr b="1" sz="1150">
                 <a:solidFill>
-                  <a:srgbClr val="F8FAFC"/>
+                  <a:srgbClr val="0F172A"/>
                 </a:solidFill>
                 <a:latin typeface="Segoe UI"/>
               </a:rPr>
@@ -8437,7 +8437,7 @@
             <a:r>
               <a:rPr sz="1150">
                 <a:solidFill>
-                  <a:srgbClr val="9CAFC9"/>
+                  <a:srgbClr val="334155"/>
                 </a:solidFill>
                 <a:latin typeface="Segoe UI"/>
               </a:rPr>
@@ -8456,7 +8456,7 @@
             <a:r>
               <a:rPr b="1" sz="1150">
                 <a:solidFill>
-                  <a:srgbClr val="F8FAFC"/>
+                  <a:srgbClr val="0F172A"/>
                 </a:solidFill>
                 <a:latin typeface="Segoe UI"/>
               </a:rPr>
@@ -8465,7 +8465,7 @@
             <a:r>
               <a:rPr sz="1150">
                 <a:solidFill>
-                  <a:srgbClr val="9CAFC9"/>
+                  <a:srgbClr val="334155"/>
                 </a:solidFill>
                 <a:latin typeface="Segoe UI"/>
               </a:rPr>
@@ -8484,7 +8484,7 @@
             <a:r>
               <a:rPr b="1" sz="1150">
                 <a:solidFill>
-                  <a:srgbClr val="F8FAFC"/>
+                  <a:srgbClr val="0F172A"/>
                 </a:solidFill>
                 <a:latin typeface="Segoe UI"/>
               </a:rPr>
@@ -8493,7 +8493,7 @@
             <a:r>
               <a:rPr sz="1150">
                 <a:solidFill>
-                  <a:srgbClr val="9CAFC9"/>
+                  <a:srgbClr val="334155"/>
                 </a:solidFill>
                 <a:latin typeface="Segoe UI"/>
               </a:rPr>
@@ -8535,7 +8535,7 @@
             <a:avLst/>
           </a:prstGeom>
           <a:solidFill>
-            <a:srgbClr val="0B0F19"/>
+            <a:srgbClr val="F8FAFC"/>
           </a:solidFill>
           <a:ln>
             <a:noFill/>
@@ -8571,18 +8571,18 @@
         </p:nvSpPr>
         <p:spPr>
           <a:xfrm>
-            <a:off x="731520" y="365760"/>
-            <a:ext cx="2651760" cy="292608"/>
+            <a:off x="731520" y="347472"/>
+            <a:ext cx="2926080" cy="292608"/>
           </a:xfrm>
           <a:prstGeom prst="roundRect">
             <a:avLst/>
           </a:prstGeom>
           <a:solidFill>
-            <a:srgbClr val="161E2E"/>
+            <a:srgbClr val="ECFDF5"/>
           </a:solidFill>
           <a:ln w="12700">
             <a:solidFill>
-              <a:srgbClr val="10B981"/>
+              <a:srgbClr val="A7F3D0"/>
             </a:solidFill>
           </a:ln>
         </p:spPr>
@@ -8607,7 +8607,7 @@
             <a:pPr algn="ctr">
               <a:defRPr sz="1000" b="1">
                 <a:solidFill>
-                  <a:srgbClr val="10B981"/>
+                  <a:srgbClr val="059669"/>
                 </a:solidFill>
                 <a:latin typeface="Segoe UI"/>
               </a:defRPr>
@@ -8626,7 +8626,7 @@
         </p:nvSpPr>
         <p:spPr>
           <a:xfrm>
-            <a:off x="731520" y="713232"/>
+            <a:off x="731520" y="694944"/>
             <a:ext cx="10698480" cy="594360"/>
           </a:xfrm>
           <a:prstGeom prst="rect">
@@ -8643,7 +8643,7 @@
             <a:pPr>
               <a:defRPr sz="2400" b="1">
                 <a:solidFill>
-                  <a:srgbClr val="F8FAFC"/>
+                  <a:srgbClr val="0F172A"/>
                 </a:solidFill>
                 <a:latin typeface="Segoe UI"/>
               </a:defRPr>
@@ -8669,11 +8669,11 @@
             <a:avLst/>
           </a:prstGeom>
           <a:solidFill>
-            <a:srgbClr val="161E2E"/>
+            <a:srgbClr val="FFFFFF"/>
           </a:solidFill>
-          <a:ln w="12700">
+          <a:ln w="15240">
             <a:solidFill>
-              <a:srgbClr val="2D3C54"/>
+              <a:srgbClr val="E2E8F0"/>
             </a:solidFill>
           </a:ln>
         </p:spPr>
@@ -8724,7 +8724,7 @@
             <a:pPr>
               <a:defRPr sz="1400" b="1">
                 <a:solidFill>
-                  <a:srgbClr val="10B981"/>
+                  <a:srgbClr val="059669"/>
                 </a:solidFill>
                 <a:latin typeface="Segoe UI"/>
               </a:defRPr>
@@ -8768,7 +8768,7 @@
             <a:r>
               <a:rPr b="1" sz="1150">
                 <a:solidFill>
-                  <a:srgbClr val="F8FAFC"/>
+                  <a:srgbClr val="0F172A"/>
                 </a:solidFill>
                 <a:latin typeface="Segoe UI"/>
               </a:rPr>
@@ -8777,7 +8777,7 @@
             <a:r>
               <a:rPr sz="1150">
                 <a:solidFill>
-                  <a:srgbClr val="9CAFC9"/>
+                  <a:srgbClr val="334155"/>
                 </a:solidFill>
                 <a:latin typeface="Segoe UI"/>
               </a:rPr>
@@ -8797,7 +8797,7 @@
             <a:r>
               <a:rPr b="1" sz="1150">
                 <a:solidFill>
-                  <a:srgbClr val="F8FAFC"/>
+                  <a:srgbClr val="0F172A"/>
                 </a:solidFill>
                 <a:latin typeface="Segoe UI"/>
               </a:rPr>
@@ -8806,7 +8806,7 @@
             <a:r>
               <a:rPr sz="1150">
                 <a:solidFill>
-                  <a:srgbClr val="9CAFC9"/>
+                  <a:srgbClr val="334155"/>
                 </a:solidFill>
                 <a:latin typeface="Segoe UI"/>
               </a:rPr>
@@ -8826,7 +8826,7 @@
             <a:r>
               <a:rPr b="1" sz="1150">
                 <a:solidFill>
-                  <a:srgbClr val="F8FAFC"/>
+                  <a:srgbClr val="0F172A"/>
                 </a:solidFill>
                 <a:latin typeface="Segoe UI"/>
               </a:rPr>
@@ -8835,7 +8835,7 @@
             <a:r>
               <a:rPr sz="1150">
                 <a:solidFill>
-                  <a:srgbClr val="9CAFC9"/>
+                  <a:srgbClr val="334155"/>
                 </a:solidFill>
                 <a:latin typeface="Segoe UI"/>
               </a:rPr>
@@ -8855,7 +8855,7 @@
             <a:r>
               <a:rPr b="1" sz="1150">
                 <a:solidFill>
-                  <a:srgbClr val="F8FAFC"/>
+                  <a:srgbClr val="0F172A"/>
                 </a:solidFill>
                 <a:latin typeface="Segoe UI"/>
               </a:rPr>
@@ -8864,7 +8864,7 @@
             <a:r>
               <a:rPr sz="1150">
                 <a:solidFill>
-                  <a:srgbClr val="9CAFC9"/>
+                  <a:srgbClr val="334155"/>
                 </a:solidFill>
                 <a:latin typeface="Segoe UI"/>
               </a:rPr>
@@ -8888,11 +8888,11 @@
             <a:avLst/>
           </a:prstGeom>
           <a:solidFill>
-            <a:srgbClr val="161E2E"/>
+            <a:srgbClr val="FFFFFF"/>
           </a:solidFill>
-          <a:ln w="12700">
+          <a:ln w="15240">
             <a:solidFill>
-              <a:srgbClr val="2D3C54"/>
+              <a:srgbClr val="E2E8F0"/>
             </a:solidFill>
           </a:ln>
         </p:spPr>
@@ -8943,7 +8943,7 @@
             <a:pPr>
               <a:defRPr sz="1400" b="1">
                 <a:solidFill>
-                  <a:srgbClr val="06B6D4"/>
+                  <a:srgbClr val="0284C7"/>
                 </a:solidFill>
                 <a:latin typeface="Segoe UI"/>
               </a:defRPr>
@@ -8969,11 +8969,11 @@
             <a:avLst/>
           </a:prstGeom>
           <a:solidFill>
-            <a:srgbClr val="0F172A"/>
+            <a:srgbClr val="FFFFFF"/>
           </a:solidFill>
-          <a:ln w="12700">
+          <a:ln w="15240">
             <a:solidFill>
-              <a:srgbClr val="334155"/>
+              <a:srgbClr val="E2E8F0"/>
             </a:solidFill>
           </a:ln>
         </p:spPr>
@@ -9056,7 +9056,7 @@
             <a:avLst/>
           </a:prstGeom>
           <a:solidFill>
-            <a:srgbClr val="0B0F19"/>
+            <a:srgbClr val="F8FAFC"/>
           </a:solidFill>
           <a:ln>
             <a:noFill/>
@@ -9092,18 +9092,18 @@
         </p:nvSpPr>
         <p:spPr>
           <a:xfrm>
-            <a:off x="731520" y="365760"/>
-            <a:ext cx="2651760" cy="292608"/>
+            <a:off x="731520" y="347472"/>
+            <a:ext cx="2926080" cy="292608"/>
           </a:xfrm>
           <a:prstGeom prst="roundRect">
             <a:avLst/>
           </a:prstGeom>
           <a:solidFill>
-            <a:srgbClr val="161E2E"/>
+            <a:srgbClr val="ECFDF5"/>
           </a:solidFill>
           <a:ln w="12700">
             <a:solidFill>
-              <a:srgbClr val="10B981"/>
+              <a:srgbClr val="A7F3D0"/>
             </a:solidFill>
           </a:ln>
         </p:spPr>
@@ -9128,7 +9128,7 @@
             <a:pPr algn="ctr">
               <a:defRPr sz="1000" b="1">
                 <a:solidFill>
-                  <a:srgbClr val="10B981"/>
+                  <a:srgbClr val="059669"/>
                 </a:solidFill>
                 <a:latin typeface="Segoe UI"/>
               </a:defRPr>
@@ -9147,7 +9147,7 @@
         </p:nvSpPr>
         <p:spPr>
           <a:xfrm>
-            <a:off x="731520" y="713232"/>
+            <a:off x="731520" y="694944"/>
             <a:ext cx="10698480" cy="594360"/>
           </a:xfrm>
           <a:prstGeom prst="rect">
@@ -9164,7 +9164,7 @@
             <a:pPr>
               <a:defRPr sz="2400" b="1">
                 <a:solidFill>
-                  <a:srgbClr val="F8FAFC"/>
+                  <a:srgbClr val="0F172A"/>
                 </a:solidFill>
                 <a:latin typeface="Segoe UI"/>
               </a:defRPr>
@@ -9190,11 +9190,11 @@
             <a:avLst/>
           </a:prstGeom>
           <a:solidFill>
-            <a:srgbClr val="161E2E"/>
+            <a:srgbClr val="FFFFFF"/>
           </a:solidFill>
-          <a:ln w="12700">
+          <a:ln w="15240">
             <a:solidFill>
-              <a:srgbClr val="2D3C54"/>
+              <a:srgbClr val="E2E8F0"/>
             </a:solidFill>
           </a:ln>
         </p:spPr>
@@ -9245,7 +9245,7 @@
             <a:pPr>
               <a:defRPr sz="1400" b="1">
                 <a:solidFill>
-                  <a:srgbClr val="10B981"/>
+                  <a:srgbClr val="059669"/>
                 </a:solidFill>
                 <a:latin typeface="Segoe UI"/>
               </a:defRPr>
@@ -9289,7 +9289,7 @@
             <a:r>
               <a:rPr b="1" sz="1150">
                 <a:solidFill>
-                  <a:srgbClr val="F8FAFC"/>
+                  <a:srgbClr val="0F172A"/>
                 </a:solidFill>
                 <a:latin typeface="Segoe UI"/>
               </a:rPr>
@@ -9298,7 +9298,7 @@
             <a:r>
               <a:rPr sz="1150">
                 <a:solidFill>
-                  <a:srgbClr val="9CAFC9"/>
+                  <a:srgbClr val="334155"/>
                 </a:solidFill>
                 <a:latin typeface="Segoe UI"/>
               </a:rPr>
@@ -9320,7 +9320,7 @@
             <a:r>
               <a:rPr b="1" sz="1150">
                 <a:solidFill>
-                  <a:srgbClr val="F8FAFC"/>
+                  <a:srgbClr val="0F172A"/>
                 </a:solidFill>
                 <a:latin typeface="Segoe UI"/>
               </a:rPr>
@@ -9329,7 +9329,7 @@
             <a:r>
               <a:rPr sz="1150">
                 <a:solidFill>
-                  <a:srgbClr val="9CAFC9"/>
+                  <a:srgbClr val="334155"/>
                 </a:solidFill>
                 <a:latin typeface="Segoe UI"/>
               </a:rPr>
@@ -9351,7 +9351,7 @@
             <a:r>
               <a:rPr b="1" sz="1150">
                 <a:solidFill>
-                  <a:srgbClr val="F8FAFC"/>
+                  <a:srgbClr val="0F172A"/>
                 </a:solidFill>
                 <a:latin typeface="Segoe UI"/>
               </a:rPr>
@@ -9360,7 +9360,7 @@
             <a:r>
               <a:rPr sz="1150">
                 <a:solidFill>
-                  <a:srgbClr val="9CAFC9"/>
+                  <a:srgbClr val="334155"/>
                 </a:solidFill>
                 <a:latin typeface="Segoe UI"/>
               </a:rPr>
@@ -9384,11 +9384,11 @@
             <a:avLst/>
           </a:prstGeom>
           <a:solidFill>
-            <a:srgbClr val="161E2E"/>
+            <a:srgbClr val="FFFFFF"/>
           </a:solidFill>
-          <a:ln w="12700">
+          <a:ln w="15240">
             <a:solidFill>
-              <a:srgbClr val="2D3C54"/>
+              <a:srgbClr val="E2E8F0"/>
             </a:solidFill>
           </a:ln>
         </p:spPr>
@@ -9439,7 +9439,7 @@
             <a:pPr>
               <a:defRPr sz="1400" b="1">
                 <a:solidFill>
-                  <a:srgbClr val="06B6D4"/>
+                  <a:srgbClr val="0284C7"/>
                 </a:solidFill>
                 <a:latin typeface="Segoe UI"/>
               </a:defRPr>
@@ -9465,11 +9465,11 @@
             <a:avLst/>
           </a:prstGeom>
           <a:solidFill>
-            <a:srgbClr val="0F172A"/>
+            <a:srgbClr val="FFFFFF"/>
           </a:solidFill>
-          <a:ln w="12700">
+          <a:ln w="15240">
             <a:solidFill>
-              <a:srgbClr val="334155"/>
+              <a:srgbClr val="E2E8F0"/>
             </a:solidFill>
           </a:ln>
         </p:spPr>
@@ -9552,7 +9552,7 @@
             <a:avLst/>
           </a:prstGeom>
           <a:solidFill>
-            <a:srgbClr val="0B0F19"/>
+            <a:srgbClr val="F8FAFC"/>
           </a:solidFill>
           <a:ln>
             <a:noFill/>
@@ -9588,18 +9588,18 @@
         </p:nvSpPr>
         <p:spPr>
           <a:xfrm>
-            <a:off x="731520" y="365760"/>
-            <a:ext cx="2651760" cy="292608"/>
+            <a:off x="731520" y="347472"/>
+            <a:ext cx="2926080" cy="292608"/>
           </a:xfrm>
           <a:prstGeom prst="roundRect">
             <a:avLst/>
           </a:prstGeom>
           <a:solidFill>
-            <a:srgbClr val="161E2E"/>
+            <a:srgbClr val="EFF6FF"/>
           </a:solidFill>
           <a:ln w="12700">
             <a:solidFill>
-              <a:srgbClr val="06B6D4"/>
+              <a:srgbClr val="BFDBFE"/>
             </a:solidFill>
           </a:ln>
         </p:spPr>
@@ -9624,7 +9624,7 @@
             <a:pPr algn="ctr">
               <a:defRPr sz="1000" b="1">
                 <a:solidFill>
-                  <a:srgbClr val="06B6D4"/>
+                  <a:srgbClr val="0284C7"/>
                 </a:solidFill>
                 <a:latin typeface="Segoe UI"/>
               </a:defRPr>
@@ -9643,7 +9643,7 @@
         </p:nvSpPr>
         <p:spPr>
           <a:xfrm>
-            <a:off x="731520" y="713232"/>
+            <a:off x="731520" y="694944"/>
             <a:ext cx="10698480" cy="594360"/>
           </a:xfrm>
           <a:prstGeom prst="rect">
@@ -9660,7 +9660,7 @@
             <a:pPr>
               <a:defRPr sz="2400" b="1">
                 <a:solidFill>
-                  <a:srgbClr val="F8FAFC"/>
+                  <a:srgbClr val="0F172A"/>
                 </a:solidFill>
                 <a:latin typeface="Segoe UI"/>
               </a:defRPr>
@@ -9686,11 +9686,11 @@
             <a:avLst/>
           </a:prstGeom>
           <a:solidFill>
-            <a:srgbClr val="161E2E"/>
+            <a:srgbClr val="FFFFFF"/>
           </a:solidFill>
-          <a:ln w="12700">
+          <a:ln w="15240">
             <a:solidFill>
-              <a:srgbClr val="2D3C54"/>
+              <a:srgbClr val="E2E8F0"/>
             </a:solidFill>
           </a:ln>
         </p:spPr>
@@ -9741,7 +9741,7 @@
             <a:pPr>
               <a:defRPr sz="1400" b="1">
                 <a:solidFill>
-                  <a:srgbClr val="06B6D4"/>
+                  <a:srgbClr val="0284C7"/>
                 </a:solidFill>
                 <a:latin typeface="Segoe UI"/>
               </a:defRPr>
@@ -9785,7 +9785,7 @@
             <a:r>
               <a:rPr b="1" sz="1150">
                 <a:solidFill>
-                  <a:srgbClr val="F8FAFC"/>
+                  <a:srgbClr val="0F172A"/>
                 </a:solidFill>
                 <a:latin typeface="Segoe UI"/>
               </a:rPr>
@@ -9794,7 +9794,7 @@
             <a:r>
               <a:rPr sz="1150">
                 <a:solidFill>
-                  <a:srgbClr val="9CAFC9"/>
+                  <a:srgbClr val="334155"/>
                 </a:solidFill>
                 <a:latin typeface="Segoe UI"/>
               </a:rPr>
@@ -9813,7 +9813,7 @@
             <a:r>
               <a:rPr b="1" sz="1150">
                 <a:solidFill>
-                  <a:srgbClr val="F8FAFC"/>
+                  <a:srgbClr val="0F172A"/>
                 </a:solidFill>
                 <a:latin typeface="Segoe UI"/>
               </a:rPr>
@@ -9822,7 +9822,7 @@
             <a:r>
               <a:rPr sz="1150">
                 <a:solidFill>
-                  <a:srgbClr val="9CAFC9"/>
+                  <a:srgbClr val="334155"/>
                 </a:solidFill>
                 <a:latin typeface="Segoe UI"/>
               </a:rPr>
@@ -9843,7 +9843,7 @@
             <a:r>
               <a:rPr b="1" sz="1150">
                 <a:solidFill>
-                  <a:srgbClr val="F8FAFC"/>
+                  <a:srgbClr val="0F172A"/>
                 </a:solidFill>
                 <a:latin typeface="Segoe UI"/>
               </a:rPr>
@@ -9852,7 +9852,7 @@
             <a:r>
               <a:rPr sz="1150">
                 <a:solidFill>
-                  <a:srgbClr val="9CAFC9"/>
+                  <a:srgbClr val="334155"/>
                 </a:solidFill>
                 <a:latin typeface="Segoe UI"/>
               </a:rPr>
@@ -9876,11 +9876,11 @@
             <a:avLst/>
           </a:prstGeom>
           <a:solidFill>
-            <a:srgbClr val="0F172A"/>
+            <a:srgbClr val="F1F5F9"/>
           </a:solidFill>
-          <a:ln w="12700">
+          <a:ln w="15240">
             <a:solidFill>
-              <a:srgbClr val="334155"/>
+              <a:srgbClr val="CBD5E1"/>
             </a:solidFill>
           </a:ln>
         </p:spPr>
@@ -9931,7 +9931,7 @@
             <a:pPr>
               <a:defRPr sz="1050">
                 <a:solidFill>
-                  <a:srgbClr val="38BDF8"/>
+                  <a:srgbClr val="0F172A"/>
                 </a:solidFill>
                 <a:latin typeface="Consolas"/>
               </a:defRPr>
@@ -9973,11 +9973,11 @@
             <a:avLst/>
           </a:prstGeom>
           <a:solidFill>
-            <a:srgbClr val="161E2E"/>
+            <a:srgbClr val="FFFFFF"/>
           </a:solidFill>
-          <a:ln w="12700">
+          <a:ln w="15240">
             <a:solidFill>
-              <a:srgbClr val="2D3C54"/>
+              <a:srgbClr val="E2E8F0"/>
             </a:solidFill>
           </a:ln>
         </p:spPr>
@@ -10028,7 +10028,7 @@
             <a:pPr>
               <a:defRPr sz="1400" b="1">
                 <a:solidFill>
-                  <a:srgbClr val="EF4444"/>
+                  <a:srgbClr val="DC2626"/>
                 </a:solidFill>
                 <a:latin typeface="Segoe UI"/>
               </a:defRPr>
@@ -10054,11 +10054,11 @@
             <a:avLst/>
           </a:prstGeom>
           <a:solidFill>
-            <a:srgbClr val="0F172A"/>
+            <a:srgbClr val="FFFFFF"/>
           </a:solidFill>
-          <a:ln w="12700">
+          <a:ln w="15240">
             <a:solidFill>
-              <a:srgbClr val="334155"/>
+              <a:srgbClr val="E2E8F0"/>
             </a:solidFill>
           </a:ln>
         </p:spPr>

</xml_diff>